<commit_message>
Build final presentation deck
</commit_message>
<xml_diff>
--- a/docs/slides/deck.pptx
+++ b/docs/slides/deck.pptx
@@ -15,6 +15,13 @@
     <p:sldId id="263" r:id="rId15"/>
     <p:sldId id="264" r:id="rId16"/>
     <p:sldId id="265" r:id="rId17"/>
+    <p:sldId id="266" r:id="rId18"/>
+    <p:sldId id="267" r:id="rId19"/>
+    <p:sldId id="268" r:id="rId20"/>
+    <p:sldId id="269" r:id="rId21"/>
+    <p:sldId id="270" r:id="rId22"/>
+    <p:sldId id="271" r:id="rId23"/>
+    <p:sldId id="272" r:id="rId24"/>
   </p:sldIdLst>
   <p:sldSz cx="12191695" cy="6858000" type="screen4x3"/>
   <p:notesSz cx="6858000" cy="9144000"/>
@@ -581,7 +588,497 @@
           <a:lstStyle/>
           <a:p>
             <a:r>
-              <a:t>Placeholder. Person B replaces this slide with Experiment 3 to the end of the deck.</a:t>
+              <a:t>This is our direct test of whether tweet-trained models transfer to news. The paper reports 63% for SVM on 100 private articles. On 1,001 public articles, our tuned tweet SVM scores 58.4%, below the 59.8% always-Right baseline. Bernoulli and Multinomial Naive Bayes are slightly above that baseline at 60.6% and 60.5%.</a:t>
+            </a:r>
+          </a:p>
+        </p:txBody>
+      </p:sp>
+      <p:sp>
+        <p:nvSpPr>
+          <p:cNvPr id="4" name="Slide Number Placeholder 3"/>
+          <p:cNvSpPr>
+            <a:spLocks noGrp="1"/>
+          </p:cNvSpPr>
+          <p:nvPr>
+            <p:ph type="sldNum" idx="5" sz="quarter"/>
+          </p:nvPr>
+        </p:nvSpPr>
+        <p:spPr/>
+      </p:sp>
+    </p:spTree>
+  </p:cSld>
+  <p:clrMapOvr>
+    <a:masterClrMapping/>
+  </p:clrMapOvr>
+</p:notes>
+</file>
+
+<file path=ppt/notesSlides/notesSlide11.xml><?xml version="1.0" encoding="utf-8"?>
+<p:notes xmlns:a="http://schemas.openxmlformats.org/drawingml/2006/main" xmlns:p="http://schemas.openxmlformats.org/presentationml/2006/main" xmlns:r="http://schemas.openxmlformats.org/officeDocument/2006/relationships">
+  <p:cSld>
+    <p:spTree>
+      <p:nvGrpSpPr>
+        <p:cNvPr id="1" name=""/>
+        <p:cNvGrpSpPr/>
+        <p:nvPr/>
+      </p:nvGrpSpPr>
+      <p:grpSpPr>
+        <a:xfrm>
+          <a:off x="0" y="0"/>
+          <a:ext cx="0" cy="0"/>
+          <a:chOff x="0" y="0"/>
+          <a:chExt cx="0" cy="0"/>
+        </a:xfrm>
+      </p:grpSpPr>
+      <p:sp>
+        <p:nvSpPr>
+          <p:cNvPr id="2" name="Slide Image Placeholder 1"/>
+          <p:cNvSpPr>
+            <a:spLocks noGrp="1"/>
+          </p:cNvSpPr>
+          <p:nvPr>
+            <p:ph type="sldImg" idx="2"/>
+          </p:nvPr>
+        </p:nvSpPr>
+        <p:spPr/>
+      </p:sp>
+      <p:sp>
+        <p:nvSpPr>
+          <p:cNvPr id="3" name="Notes Placeholder 2"/>
+          <p:cNvSpPr>
+            <a:spLocks noGrp="1"/>
+          </p:cNvSpPr>
+          <p:nvPr>
+            <p:ph type="body" idx="3" sz="quarter"/>
+          </p:nvPr>
+        </p:nvSpPr>
+        <p:spPr/>
+        <p:txBody>
+          <a:bodyPr/>
+          <a:lstStyle/>
+          <a:p>
+            <a:r>
+              <a:t>Transfer errors vary by outlet. CNN is below the 50% line in this chart, while some outlets are substantially higher. Examples include a CNN report on spending cuts classified as Right and a Salon article mentioning conservative politics classified as Right. This suggests that labels inherited from an outlet do not always match the language of one article.</a:t>
+            </a:r>
+          </a:p>
+        </p:txBody>
+      </p:sp>
+      <p:sp>
+        <p:nvSpPr>
+          <p:cNvPr id="4" name="Slide Number Placeholder 3"/>
+          <p:cNvSpPr>
+            <a:spLocks noGrp="1"/>
+          </p:cNvSpPr>
+          <p:nvPr>
+            <p:ph type="sldNum" idx="5" sz="quarter"/>
+          </p:nvPr>
+        </p:nvSpPr>
+        <p:spPr/>
+      </p:sp>
+    </p:spTree>
+  </p:cSld>
+  <p:clrMapOvr>
+    <a:masterClrMapping/>
+  </p:clrMapOvr>
+</p:notes>
+</file>
+
+<file path=ppt/notesSlides/notesSlide12.xml><?xml version="1.0" encoding="utf-8"?>
+<p:notes xmlns:a="http://schemas.openxmlformats.org/drawingml/2006/main" xmlns:p="http://schemas.openxmlformats.org/presentationml/2006/main" xmlns:r="http://schemas.openxmlformats.org/officeDocument/2006/relationships">
+  <p:cSld>
+    <p:spTree>
+      <p:nvGrpSpPr>
+        <p:cNvPr id="1" name=""/>
+        <p:cNvGrpSpPr/>
+        <p:nvPr/>
+      </p:nvGrpSpPr>
+      <p:grpSpPr>
+        <a:xfrm>
+          <a:off x="0" y="0"/>
+          <a:ext cx="0" cy="0"/>
+          <a:chOff x="0" y="0"/>
+          <a:chExt cx="0" cy="0"/>
+        </a:xfrm>
+      </p:grpSpPr>
+      <p:sp>
+        <p:nvSpPr>
+          <p:cNvPr id="2" name="Slide Image Placeholder 1"/>
+          <p:cNvSpPr>
+            <a:spLocks noGrp="1"/>
+          </p:cNvSpPr>
+          <p:nvPr>
+            <p:ph type="sldImg" idx="2"/>
+          </p:nvPr>
+        </p:nvSpPr>
+        <p:spPr/>
+      </p:sp>
+      <p:sp>
+        <p:nvSpPr>
+          <p:cNvPr id="3" name="Notes Placeholder 2"/>
+          <p:cNvSpPr>
+            <a:spLocks noGrp="1"/>
+          </p:cNvSpPr>
+          <p:nvPr>
+            <p:ph type="body" idx="3" sz="quarter"/>
+          </p:nvPr>
+        </p:nvSpPr>
+        <p:spPr/>
+        <p:txBody>
+          <a:bodyPr/>
+          <a:lstStyle/>
+          <a:p>
+            <a:r>
+              <a:t>We selected 50-word chunks using the training validation data. Chunk voting gives Bernoulli Naive Bayes a small accuracy increase from 60.6% to 60.8%, but it drops tuned LinearSVC from 58.4% to 51.8%. The result is mixed, so we do not claim that chunking is a general improvement.</a:t>
+            </a:r>
+          </a:p>
+        </p:txBody>
+      </p:sp>
+      <p:sp>
+        <p:nvSpPr>
+          <p:cNvPr id="4" name="Slide Number Placeholder 3"/>
+          <p:cNvSpPr>
+            <a:spLocks noGrp="1"/>
+          </p:cNvSpPr>
+          <p:nvPr>
+            <p:ph type="sldNum" idx="5" sz="quarter"/>
+          </p:nvPr>
+        </p:nvSpPr>
+        <p:spPr/>
+      </p:sp>
+    </p:spTree>
+  </p:cSld>
+  <p:clrMapOvr>
+    <a:masterClrMapping/>
+  </p:clrMapOvr>
+</p:notes>
+</file>
+
+<file path=ppt/notesSlides/notesSlide13.xml><?xml version="1.0" encoding="utf-8"?>
+<p:notes xmlns:a="http://schemas.openxmlformats.org/drawingml/2006/main" xmlns:p="http://schemas.openxmlformats.org/presentationml/2006/main" xmlns:r="http://schemas.openxmlformats.org/officeDocument/2006/relationships">
+  <p:cSld>
+    <p:spTree>
+      <p:nvGrpSpPr>
+        <p:cNvPr id="1" name=""/>
+        <p:cNvGrpSpPr/>
+        <p:nvPr/>
+      </p:nvGrpSpPr>
+      <p:grpSpPr>
+        <a:xfrm>
+          <a:off x="0" y="0"/>
+          <a:ext cx="0" cy="0"/>
+          <a:chOff x="0" y="0"/>
+          <a:chExt cx="0" cy="0"/>
+        </a:xfrm>
+      </p:grpSpPr>
+      <p:sp>
+        <p:nvSpPr>
+          <p:cNvPr id="2" name="Slide Image Placeholder 1"/>
+          <p:cNvSpPr>
+            <a:spLocks noGrp="1"/>
+          </p:cNvSpPr>
+          <p:nvPr>
+            <p:ph type="sldImg" idx="2"/>
+          </p:nvPr>
+        </p:nvSpPr>
+        <p:spPr/>
+      </p:sp>
+      <p:sp>
+        <p:nvSpPr>
+          <p:cNvPr id="3" name="Notes Placeholder 2"/>
+          <p:cNvSpPr>
+            <a:spLocks noGrp="1"/>
+          </p:cNvSpPr>
+          <p:nvPr>
+            <p:ph type="body" idx="3" sz="quarter"/>
+          </p:nvPr>
+        </p:nvSpPr>
+        <p:spPr/>
+        <p:txBody>
+          <a:bodyPr/>
+          <a:lstStyle/>
+          <a:p>
+            <a:r>
+              <a:t>Training on news articles reduces the domain mismatch. LinearSVC scores 66.5% accuracy and 65.8% macro F1, which is 6.7 percentage points above the 59.8% always-Right baseline. The three-class Left, Center, Right version remains harder: Multinomial Naive Bayes is best there at 53.7% accuracy.</a:t>
+            </a:r>
+          </a:p>
+        </p:txBody>
+      </p:sp>
+      <p:sp>
+        <p:nvSpPr>
+          <p:cNvPr id="4" name="Slide Number Placeholder 3"/>
+          <p:cNvSpPr>
+            <a:spLocks noGrp="1"/>
+          </p:cNvSpPr>
+          <p:nvPr>
+            <p:ph type="sldNum" idx="5" sz="quarter"/>
+          </p:nvPr>
+        </p:nvSpPr>
+        <p:spPr/>
+      </p:sp>
+    </p:spTree>
+  </p:cSld>
+  <p:clrMapOvr>
+    <a:masterClrMapping/>
+  </p:clrMapOvr>
+</p:notes>
+</file>
+
+<file path=ppt/notesSlides/notesSlide14.xml><?xml version="1.0" encoding="utf-8"?>
+<p:notes xmlns:a="http://schemas.openxmlformats.org/drawingml/2006/main" xmlns:p="http://schemas.openxmlformats.org/presentationml/2006/main" xmlns:r="http://schemas.openxmlformats.org/officeDocument/2006/relationships">
+  <p:cSld>
+    <p:spTree>
+      <p:nvGrpSpPr>
+        <p:cNvPr id="1" name=""/>
+        <p:cNvGrpSpPr/>
+        <p:nvPr/>
+      </p:nvGrpSpPr>
+      <p:grpSpPr>
+        <a:xfrm>
+          <a:off x="0" y="0"/>
+          <a:ext cx="0" cy="0"/>
+          <a:chOff x="0" y="0"/>
+          <a:chExt cx="0" cy="0"/>
+        </a:xfrm>
+      </p:grpSpPr>
+      <p:sp>
+        <p:nvSpPr>
+          <p:cNvPr id="2" name="Slide Image Placeholder 1"/>
+          <p:cNvSpPr>
+            <a:spLocks noGrp="1"/>
+          </p:cNvSpPr>
+          <p:nvPr>
+            <p:ph type="sldImg" idx="2"/>
+          </p:nvPr>
+        </p:nvSpPr>
+        <p:spPr/>
+      </p:sp>
+      <p:sp>
+        <p:nvSpPr>
+          <p:cNvPr id="3" name="Notes Placeholder 2"/>
+          <p:cNvSpPr>
+            <a:spLocks noGrp="1"/>
+          </p:cNvSpPr>
+          <p:nvPr>
+            <p:ph type="body" idx="3" sz="quarter"/>
+          </p:nvPr>
+        </p:nvSpPr>
+        <p:spPr/>
+        <p:txBody>
+          <a:bodyPr/>
+          <a:lstStyle/>
+          <a:p>
+            <a:r>
+              <a:t>Follow docs/demo_script.md. First, score the Breitbart article, where the article-trained model correctly predicts Right. Second, show the CNN example that the article model predicts as Right, then switch to the tweet-trained SVM, which predicts Left. Third, paste the prepared free-text sentence and point out the near-even result. Keep this slide and the live walk-through to these three steps.</a:t>
+            </a:r>
+          </a:p>
+        </p:txBody>
+      </p:sp>
+      <p:sp>
+        <p:nvSpPr>
+          <p:cNvPr id="4" name="Slide Number Placeholder 3"/>
+          <p:cNvSpPr>
+            <a:spLocks noGrp="1"/>
+          </p:cNvSpPr>
+          <p:nvPr>
+            <p:ph type="sldNum" idx="5" sz="quarter"/>
+          </p:nvPr>
+        </p:nvSpPr>
+        <p:spPr/>
+      </p:sp>
+    </p:spTree>
+  </p:cSld>
+  <p:clrMapOvr>
+    <a:masterClrMapping/>
+  </p:clrMapOvr>
+</p:notes>
+</file>
+
+<file path=ppt/notesSlides/notesSlide15.xml><?xml version="1.0" encoding="utf-8"?>
+<p:notes xmlns:a="http://schemas.openxmlformats.org/drawingml/2006/main" xmlns:p="http://schemas.openxmlformats.org/presentationml/2006/main" xmlns:r="http://schemas.openxmlformats.org/officeDocument/2006/relationships">
+  <p:cSld>
+    <p:spTree>
+      <p:nvGrpSpPr>
+        <p:cNvPr id="1" name=""/>
+        <p:cNvGrpSpPr/>
+        <p:nvPr/>
+      </p:nvGrpSpPr>
+      <p:grpSpPr>
+        <a:xfrm>
+          <a:off x="0" y="0"/>
+          <a:ext cx="0" cy="0"/>
+          <a:chOff x="0" y="0"/>
+          <a:chExt cx="0" cy="0"/>
+        </a:xfrm>
+      </p:grpSpPr>
+      <p:sp>
+        <p:nvSpPr>
+          <p:cNvPr id="2" name="Slide Image Placeholder 1"/>
+          <p:cNvSpPr>
+            <a:spLocks noGrp="1"/>
+          </p:cNvSpPr>
+          <p:nvPr>
+            <p:ph type="sldImg" idx="2"/>
+          </p:nvPr>
+        </p:nvSpPr>
+        <p:spPr/>
+      </p:sp>
+      <p:sp>
+        <p:nvSpPr>
+          <p:cNvPr id="3" name="Notes Placeholder 2"/>
+          <p:cNvSpPr>
+            <a:spLocks noGrp="1"/>
+          </p:cNvSpPr>
+          <p:nvPr>
+            <p:ph type="body" idx="3" sz="quarter"/>
+          </p:nvPr>
+        </p:nvSpPr>
+        <p:spPr/>
+        <p:txBody>
+          <a:bodyPr/>
+          <a:lstStyle/>
+          <a:p>
+            <a:r>
+              <a:t>These numbers use different test settings, so they should not be compared as if they came from the same task. Extension 1 reaches 83.3% on the grouped tweet test. Extension 3 reaches 66.5% on the article test. The article majority baseline is 59.8%, so in-domain article training provides the clearest gain on that task.</a:t>
+            </a:r>
+          </a:p>
+        </p:txBody>
+      </p:sp>
+      <p:sp>
+        <p:nvSpPr>
+          <p:cNvPr id="4" name="Slide Number Placeholder 3"/>
+          <p:cNvSpPr>
+            <a:spLocks noGrp="1"/>
+          </p:cNvSpPr>
+          <p:nvPr>
+            <p:ph type="sldNum" idx="5" sz="quarter"/>
+          </p:nvPr>
+        </p:nvSpPr>
+        <p:spPr/>
+      </p:sp>
+    </p:spTree>
+  </p:cSld>
+  <p:clrMapOvr>
+    <a:masterClrMapping/>
+  </p:clrMapOvr>
+</p:notes>
+</file>
+
+<file path=ppt/notesSlides/notesSlide16.xml><?xml version="1.0" encoding="utf-8"?>
+<p:notes xmlns:a="http://schemas.openxmlformats.org/drawingml/2006/main" xmlns:p="http://schemas.openxmlformats.org/presentationml/2006/main" xmlns:r="http://schemas.openxmlformats.org/officeDocument/2006/relationships">
+  <p:cSld>
+    <p:spTree>
+      <p:nvGrpSpPr>
+        <p:cNvPr id="1" name=""/>
+        <p:cNvGrpSpPr/>
+        <p:nvPr/>
+      </p:nvGrpSpPr>
+      <p:grpSpPr>
+        <a:xfrm>
+          <a:off x="0" y="0"/>
+          <a:ext cx="0" cy="0"/>
+          <a:chOff x="0" y="0"/>
+          <a:chExt cx="0" cy="0"/>
+        </a:xfrm>
+      </p:grpSpPr>
+      <p:sp>
+        <p:nvSpPr>
+          <p:cNvPr id="2" name="Slide Image Placeholder 1"/>
+          <p:cNvSpPr>
+            <a:spLocks noGrp="1"/>
+          </p:cNvSpPr>
+          <p:nvPr>
+            <p:ph type="sldImg" idx="2"/>
+          </p:nvPr>
+        </p:nvSpPr>
+        <p:spPr/>
+      </p:sp>
+      <p:sp>
+        <p:nvSpPr>
+          <p:cNvPr id="3" name="Notes Placeholder 2"/>
+          <p:cNvSpPr>
+            <a:spLocks noGrp="1"/>
+          </p:cNvSpPr>
+          <p:nvPr>
+            <p:ph type="body" idx="3" sz="quarter"/>
+          </p:nvPr>
+        </p:nvSpPr>
+        <p:spPr/>
+        <p:txBody>
+          <a:bodyPr/>
+          <a:lstStyle/>
+          <a:p>
+            <a:r>
+              <a:t>Our labels are proxies: a politician's party or an outlet's AllSides label. They cannot describe every individual tweet or article perfectly. Tweet-trained models also transfer poorly to news. The three-class article task reaches 53.7% at best. Future work should collect article-level labels and evaluate across time periods and outlets that were not part of development.</a:t>
+            </a:r>
+          </a:p>
+        </p:txBody>
+      </p:sp>
+      <p:sp>
+        <p:nvSpPr>
+          <p:cNvPr id="4" name="Slide Number Placeholder 3"/>
+          <p:cNvSpPr>
+            <a:spLocks noGrp="1"/>
+          </p:cNvSpPr>
+          <p:nvPr>
+            <p:ph type="sldNum" idx="5" sz="quarter"/>
+          </p:nvPr>
+        </p:nvSpPr>
+        <p:spPr/>
+      </p:sp>
+    </p:spTree>
+  </p:cSld>
+  <p:clrMapOvr>
+    <a:masterClrMapping/>
+  </p:clrMapOvr>
+</p:notes>
+</file>
+
+<file path=ppt/notesSlides/notesSlide17.xml><?xml version="1.0" encoding="utf-8"?>
+<p:notes xmlns:a="http://schemas.openxmlformats.org/drawingml/2006/main" xmlns:p="http://schemas.openxmlformats.org/presentationml/2006/main" xmlns:r="http://schemas.openxmlformats.org/officeDocument/2006/relationships">
+  <p:cSld>
+    <p:spTree>
+      <p:nvGrpSpPr>
+        <p:cNvPr id="1" name=""/>
+        <p:cNvGrpSpPr/>
+        <p:nvPr/>
+      </p:nvGrpSpPr>
+      <p:grpSpPr>
+        <a:xfrm>
+          <a:off x="0" y="0"/>
+          <a:ext cx="0" cy="0"/>
+          <a:chOff x="0" y="0"/>
+          <a:chExt cx="0" cy="0"/>
+        </a:xfrm>
+      </p:grpSpPr>
+      <p:sp>
+        <p:nvSpPr>
+          <p:cNvPr id="2" name="Slide Image Placeholder 1"/>
+          <p:cNvSpPr>
+            <a:spLocks noGrp="1"/>
+          </p:cNvSpPr>
+          <p:nvPr>
+            <p:ph type="sldImg" idx="2"/>
+          </p:nvPr>
+        </p:nvSpPr>
+        <p:spPr/>
+      </p:sp>
+      <p:sp>
+        <p:nvSpPr>
+          <p:cNvPr id="3" name="Notes Placeholder 2"/>
+          <p:cNvSpPr>
+            <a:spLocks noGrp="1"/>
+          </p:cNvSpPr>
+          <p:nvPr>
+            <p:ph type="body" idx="3" sz="quarter"/>
+          </p:nvPr>
+        </p:nvSpPr>
+        <p:spPr/>
+        <p:txBody>
+          <a:bodyPr/>
+          <a:lstStyle/>
+          <a:p>
+            <a:r>
+              <a:t>Thank the audience and invite questions. Keep the demo and results files ready in case a question needs a quick example or an exact number.</a:t>
             </a:r>
           </a:p>
         </p:txBody>
@@ -4460,7 +4957,7 @@
                 </a:solidFill>
                 <a:latin typeface="Georgia"/>
               </a:rPr>
-              <a:t>PERSON</a:t>
+              <a:t>EXPERIMENT</a:t>
             </a:r>
             <a:r>
               <a:rPr sz="2600" b="0" i="0" spc="400">
@@ -4469,33 +4966,56 @@
                 </a:solidFill>
                 <a:latin typeface="Georgia"/>
               </a:rPr>
-              <a:t> B SLIDES</a:t>
-            </a:r>
-          </a:p>
-        </p:txBody>
-      </p:sp>
-      <p:sp>
-        <p:nvSpPr>
-          <p:cNvPr id="3" name="Placeholder outline"/>
+              <a:t> 3: TWEETS TO NEWS</a:t>
+            </a:r>
+          </a:p>
+        </p:txBody>
+      </p:sp>
+      <p:pic>
+        <p:nvPicPr>
+          <p:cNvPr id="3" name="Figure exp3_comparison" descr="exp3_comparison.png"/>
+          <p:cNvPicPr>
+            <a:picLocks noChangeAspect="1"/>
+          </p:cNvPicPr>
+          <p:nvPr/>
+        </p:nvPicPr>
+        <p:blipFill>
+          <a:blip r:embed="rId2"/>
+          <a:stretch>
+            <a:fillRect/>
+          </a:stretch>
+        </p:blipFill>
+        <p:spPr>
+          <a:xfrm>
+            <a:off x="2083917" y="1097280"/>
+            <a:ext cx="8023860" cy="3703320"/>
+          </a:xfrm>
+          <a:prstGeom prst="rect">
+            <a:avLst/>
+          </a:prstGeom>
+        </p:spPr>
+      </p:pic>
+      <p:sp>
+        <p:nvSpPr>
+          <p:cNvPr id="4" name="Number 1 block"/>
           <p:cNvSpPr/>
           <p:nvPr/>
         </p:nvSpPr>
         <p:spPr>
           <a:xfrm>
-            <a:off x="548640" y="1325880"/>
-            <a:ext cx="11094415" cy="4709160"/>
+            <a:off x="548640" y="5074920"/>
+            <a:ext cx="3931920" cy="960120"/>
           </a:xfrm>
           <a:prstGeom prst="roundRect">
             <a:avLst>
-              <a:gd name="adj" fmla="val 5000"/>
+              <a:gd name="adj" fmla="val 10000"/>
             </a:avLst>
           </a:prstGeom>
-          <a:noFill/>
-          <a:ln w="25400">
-            <a:solidFill>
-              <a:srgbClr val="0A5C68"/>
-            </a:solidFill>
-            <a:prstDash val="dash"/>
+          <a:solidFill>
+            <a:srgbClr val="053944"/>
+          </a:solidFill>
+          <a:ln>
+            <a:noFill/>
           </a:ln>
           <a:effectLst/>
         </p:spPr>
@@ -4523,14 +5043,14 @@
       </p:sp>
       <p:sp>
         <p:nvSpPr>
-          <p:cNvPr id="4" name="Placeholder text"/>
+          <p:cNvPr id="5" name="Number 1 text"/>
           <p:cNvSpPr txBox="1"/>
           <p:nvPr/>
         </p:nvSpPr>
         <p:spPr>
           <a:xfrm>
-            <a:off x="1280160" y="1874519"/>
-            <a:ext cx="9631375" cy="3611880"/>
+            <a:off x="777240" y="5257800"/>
+            <a:ext cx="3474720" cy="594360"/>
           </a:xfrm>
           <a:prstGeom prst="rect">
             <a:avLst/>
@@ -4543,42 +5063,137 @@
           </a:bodyPr>
           <a:lstStyle/>
           <a:p>
-            <a:pPr algn="ctr">
-              <a:spcAft>
-                <a:spcPts val="1200"/>
-              </a:spcAft>
-            </a:pPr>
-            <a:r>
-              <a:rPr sz="1600" b="1" i="0" spc="300">
-                <a:solidFill>
-                  <a:srgbClr val="0A5C68"/>
-                </a:solidFill>
-                <a:latin typeface="Calibri"/>
-              </a:rPr>
-              <a:t>PLACEHOLDER FOR PERSON B</a:t>
-            </a:r>
-          </a:p>
-          <a:p>
-            <a:pPr algn="ctr">
+            <a:pPr algn="l">
+              <a:spcAft>
+                <a:spcPts val="400"/>
+              </a:spcAft>
+            </a:pPr>
+            <a:r>
+              <a:rPr sz="2400" b="1" i="0">
+                <a:solidFill>
+                  <a:srgbClr val="BCAC79"/>
+                </a:solidFill>
+                <a:latin typeface="Calibri"/>
+              </a:rPr>
+              <a:t>1,001</a:t>
+            </a:r>
+          </a:p>
+          <a:p>
+            <a:pPr algn="l">
               <a:spcAft>
                 <a:spcPts val="0"/>
               </a:spcAft>
             </a:pPr>
             <a:r>
-              <a:rPr sz="2000" b="0" i="0">
+              <a:rPr sz="1400" b="0" i="0">
+                <a:solidFill>
+                  <a:srgbClr val="F2EFE6"/>
+                </a:solidFill>
+                <a:latin typeface="Calibri"/>
+              </a:rPr>
+              <a:t>public unseen articles</a:t>
+            </a:r>
+          </a:p>
+        </p:txBody>
+      </p:sp>
+      <p:sp>
+        <p:nvSpPr>
+          <p:cNvPr id="6" name="Bullets"/>
+          <p:cNvSpPr txBox="1"/>
+          <p:nvPr/>
+        </p:nvSpPr>
+        <p:spPr>
+          <a:xfrm>
+            <a:off x="4937759" y="5074920"/>
+            <a:ext cx="6705295" cy="960120"/>
+          </a:xfrm>
+          <a:prstGeom prst="rect">
+            <a:avLst/>
+          </a:prstGeom>
+          <a:noFill/>
+        </p:spPr>
+        <p:txBody>
+          <a:bodyPr wrap="square" lIns="0" rIns="0" tIns="0" bIns="0" anchor="ctr">
+            <a:spAutoFit/>
+          </a:bodyPr>
+          <a:lstStyle/>
+          <a:p>
+            <a:pPr algn="l" marL="274320" indent="-274320">
+              <a:lnSpc>
+                <a:spcPct val="105000"/>
+              </a:lnSpc>
+              <a:spcAft>
+                <a:spcPts val="400"/>
+              </a:spcAft>
+              <a:buClr>
+                <a:srgbClr val="088192"/>
+              </a:buClr>
+              <a:buFont typeface="Arial"/>
+              <a:buChar char="•"/>
+            </a:pPr>
+            <a:r>
+              <a:rPr sz="1500" b="0" i="0">
                 <a:solidFill>
                   <a:srgbClr val="051218"/>
                 </a:solidFill>
                 <a:latin typeface="Calibri"/>
               </a:rPr>
-              <a:t>Experiment 3 (news articles), Extensions 2 and 3, demo, conclusions and the thank-you slide go here.</a:t>
-            </a:r>
-          </a:p>
-        </p:txBody>
-      </p:sp>
-      <p:sp>
-        <p:nvSpPr>
-          <p:cNvPr id="5" name="Footer band"/>
+              <a:t>Paper SVM: 63% on 100 private articles.</a:t>
+            </a:r>
+          </a:p>
+          <a:p>
+            <a:pPr algn="l" marL="274320" indent="-274320">
+              <a:lnSpc>
+                <a:spcPct val="105000"/>
+              </a:lnSpc>
+              <a:spcAft>
+                <a:spcPts val="400"/>
+              </a:spcAft>
+              <a:buClr>
+                <a:srgbClr val="088192"/>
+              </a:buClr>
+              <a:buFont typeface="Arial"/>
+              <a:buChar char="•"/>
+            </a:pPr>
+            <a:r>
+              <a:rPr sz="1500" b="0" i="0">
+                <a:solidFill>
+                  <a:srgbClr val="051218"/>
+                </a:solidFill>
+                <a:latin typeface="Calibri"/>
+              </a:rPr>
+              <a:t>Our tuned tweet SVM: 58.4%, below the always-Right baseline of 59.8%.</a:t>
+            </a:r>
+          </a:p>
+          <a:p>
+            <a:pPr algn="l" marL="274320" indent="-274320">
+              <a:lnSpc>
+                <a:spcPct val="105000"/>
+              </a:lnSpc>
+              <a:spcAft>
+                <a:spcPts val="400"/>
+              </a:spcAft>
+              <a:buClr>
+                <a:srgbClr val="088192"/>
+              </a:buClr>
+              <a:buFont typeface="Arial"/>
+              <a:buChar char="•"/>
+            </a:pPr>
+            <a:r>
+              <a:rPr sz="1500" b="0" i="0">
+                <a:solidFill>
+                  <a:srgbClr val="051218"/>
+                </a:solidFill>
+                <a:latin typeface="Calibri"/>
+              </a:rPr>
+              <a:t>Bernoulli and Multinomial Naive Bayes reach 60.6% and 60.5%.</a:t>
+            </a:r>
+          </a:p>
+        </p:txBody>
+      </p:sp>
+      <p:sp>
+        <p:nvSpPr>
+          <p:cNvPr id="7" name="Footer band"/>
           <p:cNvSpPr/>
           <p:nvPr/>
         </p:nvSpPr>
@@ -4622,7 +5237,7 @@
       </p:sp>
       <p:sp>
         <p:nvSpPr>
-          <p:cNvPr id="6" name="Footer section"/>
+          <p:cNvPr id="8" name="Footer section"/>
           <p:cNvSpPr txBox="1"/>
           <p:nvPr/>
         </p:nvSpPr>
@@ -4654,14 +5269,14 @@
                 </a:solidFill>
                 <a:latin typeface="Calibri"/>
               </a:rPr>
-              <a:t>PERSON B</a:t>
-            </a:r>
-          </a:p>
-        </p:txBody>
-      </p:sp>
-      <p:sp>
-        <p:nvSpPr>
-          <p:cNvPr id="7" name="Slide number"/>
+              <a:t>RESULTS</a:t>
+            </a:r>
+          </a:p>
+        </p:txBody>
+      </p:sp>
+      <p:sp>
+        <p:nvSpPr>
+          <p:cNvPr id="9" name="Slide number"/>
           <p:cNvSpPr txBox="1"/>
           <p:nvPr/>
         </p:nvSpPr>
@@ -4694,6 +5309,2749 @@
                 <a:latin typeface="Calibri"/>
               </a:rPr>
               <a:t>10</a:t>
+            </a:r>
+          </a:p>
+        </p:txBody>
+      </p:sp>
+    </p:spTree>
+  </p:cSld>
+  <p:clrMapOvr>
+    <a:masterClrMapping/>
+  </p:clrMapOvr>
+</p:sld>
+</file>
+
+<file path=ppt/slides/slide11.xml><?xml version="1.0" encoding="utf-8"?>
+<p:sld xmlns:a="http://schemas.openxmlformats.org/drawingml/2006/main" xmlns:p="http://schemas.openxmlformats.org/presentationml/2006/main" xmlns:r="http://schemas.openxmlformats.org/officeDocument/2006/relationships">
+  <p:cSld>
+    <p:bg>
+      <p:bgPr>
+        <a:solidFill>
+          <a:srgbClr val="F2EFE6"/>
+        </a:solidFill>
+        <a:effectLst/>
+      </p:bgPr>
+    </p:bg>
+    <p:spTree>
+      <p:nvGrpSpPr>
+        <p:cNvPr id="1" name=""/>
+        <p:cNvGrpSpPr/>
+        <p:nvPr/>
+      </p:nvGrpSpPr>
+      <p:grpSpPr/>
+      <p:sp>
+        <p:nvSpPr>
+          <p:cNvPr id="2" name="Title"/>
+          <p:cNvSpPr txBox="1"/>
+          <p:nvPr/>
+        </p:nvSpPr>
+        <p:spPr>
+          <a:xfrm>
+            <a:off x="548640" y="411480"/>
+            <a:ext cx="11094415" cy="548640"/>
+          </a:xfrm>
+          <a:prstGeom prst="rect">
+            <a:avLst/>
+          </a:prstGeom>
+          <a:noFill/>
+        </p:spPr>
+        <p:txBody>
+          <a:bodyPr wrap="square" lIns="0" rIns="0" tIns="0" bIns="0" anchor="ctr">
+            <a:spAutoFit/>
+          </a:bodyPr>
+          <a:lstStyle/>
+          <a:p>
+            <a:r>
+              <a:rPr sz="2600" b="1" i="0" spc="400">
+                <a:solidFill>
+                  <a:srgbClr val="051218"/>
+                </a:solidFill>
+                <a:latin typeface="Georgia"/>
+              </a:rPr>
+              <a:t>WHERE</a:t>
+            </a:r>
+            <a:r>
+              <a:rPr sz="2600" b="0" i="0" spc="400">
+                <a:solidFill>
+                  <a:srgbClr val="051218"/>
+                </a:solidFill>
+                <a:latin typeface="Georgia"/>
+              </a:rPr>
+              <a:t> THE MODEL STILL FAILS</a:t>
+            </a:r>
+          </a:p>
+        </p:txBody>
+      </p:sp>
+      <p:pic>
+        <p:nvPicPr>
+          <p:cNvPr id="3" name="Figure exp3_accuracy_by_source" descr="exp3_accuracy_by_source.png"/>
+          <p:cNvPicPr>
+            <a:picLocks noChangeAspect="1"/>
+          </p:cNvPicPr>
+          <p:nvPr/>
+        </p:nvPicPr>
+        <p:blipFill>
+          <a:blip r:embed="rId2"/>
+          <a:stretch>
+            <a:fillRect/>
+          </a:stretch>
+        </p:blipFill>
+        <p:spPr>
+          <a:xfrm>
+            <a:off x="3065858" y="1097280"/>
+            <a:ext cx="6059978" cy="3703320"/>
+          </a:xfrm>
+          <a:prstGeom prst="rect">
+            <a:avLst/>
+          </a:prstGeom>
+        </p:spPr>
+      </p:pic>
+      <p:sp>
+        <p:nvSpPr>
+          <p:cNvPr id="4" name="Bullets"/>
+          <p:cNvSpPr txBox="1"/>
+          <p:nvPr/>
+        </p:nvSpPr>
+        <p:spPr>
+          <a:xfrm>
+            <a:off x="548640" y="5074920"/>
+            <a:ext cx="11094415" cy="960120"/>
+          </a:xfrm>
+          <a:prstGeom prst="rect">
+            <a:avLst/>
+          </a:prstGeom>
+          <a:noFill/>
+        </p:spPr>
+        <p:txBody>
+          <a:bodyPr wrap="square" lIns="0" rIns="0" tIns="0" bIns="0" anchor="ctr">
+            <a:spAutoFit/>
+          </a:bodyPr>
+          <a:lstStyle/>
+          <a:p>
+            <a:pPr algn="l" marL="274320" indent="-274320">
+              <a:lnSpc>
+                <a:spcPct val="105000"/>
+              </a:lnSpc>
+              <a:spcAft>
+                <a:spcPts val="400"/>
+              </a:spcAft>
+              <a:buClr>
+                <a:srgbClr val="088192"/>
+              </a:buClr>
+              <a:buFont typeface="Arial"/>
+              <a:buChar char="•"/>
+            </a:pPr>
+            <a:r>
+              <a:rPr sz="1500" b="0" i="0">
+                <a:solidFill>
+                  <a:srgbClr val="051218"/>
+                </a:solidFill>
+                <a:latin typeface="Calibri"/>
+              </a:rPr>
+              <a:t>Accuracy changes sharply across outlets. CNN is below the 50% line.</a:t>
+            </a:r>
+          </a:p>
+          <a:p>
+            <a:pPr algn="l" marL="274320" indent="-274320">
+              <a:lnSpc>
+                <a:spcPct val="105000"/>
+              </a:lnSpc>
+              <a:spcAft>
+                <a:spcPts val="400"/>
+              </a:spcAft>
+              <a:buClr>
+                <a:srgbClr val="088192"/>
+              </a:buClr>
+              <a:buFont typeface="Arial"/>
+              <a:buChar char="•"/>
+            </a:pPr>
+            <a:r>
+              <a:rPr sz="1500" b="0" i="0">
+                <a:solidFill>
+                  <a:srgbClr val="051218"/>
+                </a:solidFill>
+                <a:latin typeface="Calibri"/>
+              </a:rPr>
+              <a:t>A report can be labelled by its outlet even when the wording is neutral.</a:t>
+            </a:r>
+          </a:p>
+          <a:p>
+            <a:pPr algn="l" marL="274320" indent="-274320">
+              <a:lnSpc>
+                <a:spcPct val="105000"/>
+              </a:lnSpc>
+              <a:spcAft>
+                <a:spcPts val="400"/>
+              </a:spcAft>
+              <a:buClr>
+                <a:srgbClr val="088192"/>
+              </a:buClr>
+              <a:buFont typeface="Arial"/>
+              <a:buChar char="•"/>
+            </a:pPr>
+            <a:r>
+              <a:rPr sz="1500" b="0" i="0">
+                <a:solidFill>
+                  <a:srgbClr val="051218"/>
+                </a:solidFill>
+                <a:latin typeface="Calibri"/>
+              </a:rPr>
+              <a:t>Words such as conservative and spending can pull a prediction the wrong way.</a:t>
+            </a:r>
+          </a:p>
+        </p:txBody>
+      </p:sp>
+      <p:sp>
+        <p:nvSpPr>
+          <p:cNvPr id="5" name="Footer band"/>
+          <p:cNvSpPr/>
+          <p:nvPr/>
+        </p:nvSpPr>
+        <p:spPr>
+          <a:xfrm>
+            <a:off x="0" y="6355080"/>
+            <a:ext cx="12191695" cy="502920"/>
+          </a:xfrm>
+          <a:prstGeom prst="rect">
+            <a:avLst/>
+          </a:prstGeom>
+          <a:solidFill>
+            <a:srgbClr val="053944"/>
+          </a:solidFill>
+          <a:ln>
+            <a:noFill/>
+          </a:ln>
+          <a:effectLst/>
+        </p:spPr>
+        <p:style>
+          <a:lnRef idx="1">
+            <a:schemeClr val="accent1"/>
+          </a:lnRef>
+          <a:fillRef idx="3">
+            <a:schemeClr val="accent1"/>
+          </a:fillRef>
+          <a:effectRef idx="2">
+            <a:schemeClr val="accent1"/>
+          </a:effectRef>
+          <a:fontRef idx="minor">
+            <a:schemeClr val="lt1"/>
+          </a:fontRef>
+        </p:style>
+        <p:txBody>
+          <a:bodyPr rtlCol="0" anchor="ctr"/>
+          <a:lstStyle/>
+          <a:p>
+            <a:pPr algn="ctr"/>
+          </a:p>
+        </p:txBody>
+      </p:sp>
+      <p:sp>
+        <p:nvSpPr>
+          <p:cNvPr id="6" name="Footer section"/>
+          <p:cNvSpPr txBox="1"/>
+          <p:nvPr/>
+        </p:nvSpPr>
+        <p:spPr>
+          <a:xfrm>
+            <a:off x="548640" y="6355080"/>
+            <a:ext cx="7315200" cy="502920"/>
+          </a:xfrm>
+          <a:prstGeom prst="rect">
+            <a:avLst/>
+          </a:prstGeom>
+          <a:noFill/>
+        </p:spPr>
+        <p:txBody>
+          <a:bodyPr wrap="square" lIns="0" rIns="0" tIns="0" bIns="0" anchor="ctr">
+            <a:spAutoFit/>
+          </a:bodyPr>
+          <a:lstStyle/>
+          <a:p>
+            <a:pPr algn="l">
+              <a:spcAft>
+                <a:spcPts val="0"/>
+              </a:spcAft>
+            </a:pPr>
+            <a:r>
+              <a:rPr sz="1100" b="0" i="0" spc="200">
+                <a:solidFill>
+                  <a:srgbClr val="F2EFE6"/>
+                </a:solidFill>
+                <a:latin typeface="Calibri"/>
+              </a:rPr>
+              <a:t>ANALYSIS</a:t>
+            </a:r>
+          </a:p>
+        </p:txBody>
+      </p:sp>
+      <p:sp>
+        <p:nvSpPr>
+          <p:cNvPr id="7" name="Slide number"/>
+          <p:cNvSpPr txBox="1"/>
+          <p:nvPr/>
+        </p:nvSpPr>
+        <p:spPr>
+          <a:xfrm>
+            <a:off x="9814255" y="6355080"/>
+            <a:ext cx="1828800" cy="502920"/>
+          </a:xfrm>
+          <a:prstGeom prst="rect">
+            <a:avLst/>
+          </a:prstGeom>
+          <a:noFill/>
+        </p:spPr>
+        <p:txBody>
+          <a:bodyPr wrap="square" lIns="0" rIns="0" tIns="0" bIns="0" anchor="ctr">
+            <a:spAutoFit/>
+          </a:bodyPr>
+          <a:lstStyle/>
+          <a:p>
+            <a:pPr algn="r">
+              <a:spcAft>
+                <a:spcPts val="0"/>
+              </a:spcAft>
+            </a:pPr>
+            <a:r>
+              <a:rPr sz="1100" b="1" i="0" spc="200">
+                <a:solidFill>
+                  <a:srgbClr val="BCAC79"/>
+                </a:solidFill>
+                <a:latin typeface="Calibri"/>
+              </a:rPr>
+              <a:t>11</a:t>
+            </a:r>
+          </a:p>
+        </p:txBody>
+      </p:sp>
+    </p:spTree>
+  </p:cSld>
+  <p:clrMapOvr>
+    <a:masterClrMapping/>
+  </p:clrMapOvr>
+</p:sld>
+</file>
+
+<file path=ppt/slides/slide12.xml><?xml version="1.0" encoding="utf-8"?>
+<p:sld xmlns:a="http://schemas.openxmlformats.org/drawingml/2006/main" xmlns:p="http://schemas.openxmlformats.org/presentationml/2006/main" xmlns:r="http://schemas.openxmlformats.org/officeDocument/2006/relationships">
+  <p:cSld>
+    <p:bg>
+      <p:bgPr>
+        <a:solidFill>
+          <a:srgbClr val="F2EFE6"/>
+        </a:solidFill>
+        <a:effectLst/>
+      </p:bgPr>
+    </p:bg>
+    <p:spTree>
+      <p:nvGrpSpPr>
+        <p:cNvPr id="1" name=""/>
+        <p:cNvGrpSpPr/>
+        <p:nvPr/>
+      </p:nvGrpSpPr>
+      <p:grpSpPr/>
+      <p:sp>
+        <p:nvSpPr>
+          <p:cNvPr id="2" name="Title"/>
+          <p:cNvSpPr txBox="1"/>
+          <p:nvPr/>
+        </p:nvSpPr>
+        <p:spPr>
+          <a:xfrm>
+            <a:off x="548640" y="411480"/>
+            <a:ext cx="11094415" cy="548640"/>
+          </a:xfrm>
+          <a:prstGeom prst="rect">
+            <a:avLst/>
+          </a:prstGeom>
+          <a:noFill/>
+        </p:spPr>
+        <p:txBody>
+          <a:bodyPr wrap="square" lIns="0" rIns="0" tIns="0" bIns="0" anchor="ctr">
+            <a:spAutoFit/>
+          </a:bodyPr>
+          <a:lstStyle/>
+          <a:p>
+            <a:r>
+              <a:rPr sz="2600" b="1" i="0" spc="400">
+                <a:solidFill>
+                  <a:srgbClr val="051218"/>
+                </a:solidFill>
+                <a:latin typeface="Georgia"/>
+              </a:rPr>
+              <a:t>EXTENSION</a:t>
+            </a:r>
+            <a:r>
+              <a:rPr sz="2600" b="0" i="0" spc="400">
+                <a:solidFill>
+                  <a:srgbClr val="051218"/>
+                </a:solidFill>
+                <a:latin typeface="Georgia"/>
+              </a:rPr>
+              <a:t> 2: CHUNK VOTING</a:t>
+            </a:r>
+          </a:p>
+        </p:txBody>
+      </p:sp>
+      <p:pic>
+        <p:nvPicPr>
+          <p:cNvPr id="3" name="Figure ext2_chunk_voting" descr="ext2_chunk_voting.png"/>
+          <p:cNvPicPr>
+            <a:picLocks noChangeAspect="1"/>
+          </p:cNvPicPr>
+          <p:nvPr/>
+        </p:nvPicPr>
+        <p:blipFill>
+          <a:blip r:embed="rId2"/>
+          <a:stretch>
+            <a:fillRect/>
+          </a:stretch>
+        </p:blipFill>
+        <p:spPr>
+          <a:xfrm>
+            <a:off x="2948025" y="1097280"/>
+            <a:ext cx="6295644" cy="3703320"/>
+          </a:xfrm>
+          <a:prstGeom prst="rect">
+            <a:avLst/>
+          </a:prstGeom>
+        </p:spPr>
+      </p:pic>
+      <p:sp>
+        <p:nvSpPr>
+          <p:cNvPr id="4" name="Number 1 block"/>
+          <p:cNvSpPr/>
+          <p:nvPr/>
+        </p:nvSpPr>
+        <p:spPr>
+          <a:xfrm>
+            <a:off x="548640" y="5074920"/>
+            <a:ext cx="3931920" cy="960120"/>
+          </a:xfrm>
+          <a:prstGeom prst="roundRect">
+            <a:avLst>
+              <a:gd name="adj" fmla="val 10000"/>
+            </a:avLst>
+          </a:prstGeom>
+          <a:solidFill>
+            <a:srgbClr val="053944"/>
+          </a:solidFill>
+          <a:ln>
+            <a:noFill/>
+          </a:ln>
+          <a:effectLst/>
+        </p:spPr>
+        <p:style>
+          <a:lnRef idx="1">
+            <a:schemeClr val="accent1"/>
+          </a:lnRef>
+          <a:fillRef idx="3">
+            <a:schemeClr val="accent1"/>
+          </a:fillRef>
+          <a:effectRef idx="2">
+            <a:schemeClr val="accent1"/>
+          </a:effectRef>
+          <a:fontRef idx="minor">
+            <a:schemeClr val="lt1"/>
+          </a:fontRef>
+        </p:style>
+        <p:txBody>
+          <a:bodyPr rtlCol="0" anchor="ctr"/>
+          <a:lstStyle/>
+          <a:p>
+            <a:pPr algn="ctr"/>
+          </a:p>
+        </p:txBody>
+      </p:sp>
+      <p:sp>
+        <p:nvSpPr>
+          <p:cNvPr id="5" name="Number 1 text"/>
+          <p:cNvSpPr txBox="1"/>
+          <p:nvPr/>
+        </p:nvSpPr>
+        <p:spPr>
+          <a:xfrm>
+            <a:off x="777240" y="5257800"/>
+            <a:ext cx="3474720" cy="594360"/>
+          </a:xfrm>
+          <a:prstGeom prst="rect">
+            <a:avLst/>
+          </a:prstGeom>
+          <a:noFill/>
+        </p:spPr>
+        <p:txBody>
+          <a:bodyPr wrap="square" lIns="0" rIns="0" tIns="0" bIns="0" anchor="ctr">
+            <a:spAutoFit/>
+          </a:bodyPr>
+          <a:lstStyle/>
+          <a:p>
+            <a:pPr algn="l">
+              <a:spcAft>
+                <a:spcPts val="400"/>
+              </a:spcAft>
+            </a:pPr>
+            <a:r>
+              <a:rPr sz="2400" b="1" i="0">
+                <a:solidFill>
+                  <a:srgbClr val="BCAC79"/>
+                </a:solidFill>
+                <a:latin typeface="Calibri"/>
+              </a:rPr>
+              <a:t>50 words</a:t>
+            </a:r>
+          </a:p>
+          <a:p>
+            <a:pPr algn="l">
+              <a:spcAft>
+                <a:spcPts val="0"/>
+              </a:spcAft>
+            </a:pPr>
+            <a:r>
+              <a:rPr sz="1400" b="0" i="0">
+                <a:solidFill>
+                  <a:srgbClr val="F2EFE6"/>
+                </a:solidFill>
+                <a:latin typeface="Calibri"/>
+              </a:rPr>
+              <a:t>chunk size chosen on validation data</a:t>
+            </a:r>
+          </a:p>
+        </p:txBody>
+      </p:sp>
+      <p:sp>
+        <p:nvSpPr>
+          <p:cNvPr id="6" name="Bullets"/>
+          <p:cNvSpPr txBox="1"/>
+          <p:nvPr/>
+        </p:nvSpPr>
+        <p:spPr>
+          <a:xfrm>
+            <a:off x="4937759" y="5074920"/>
+            <a:ext cx="6705295" cy="960120"/>
+          </a:xfrm>
+          <a:prstGeom prst="rect">
+            <a:avLst/>
+          </a:prstGeom>
+          <a:noFill/>
+        </p:spPr>
+        <p:txBody>
+          <a:bodyPr wrap="square" lIns="0" rIns="0" tIns="0" bIns="0" anchor="ctr">
+            <a:spAutoFit/>
+          </a:bodyPr>
+          <a:lstStyle/>
+          <a:p>
+            <a:pPr algn="l" marL="274320" indent="-274320">
+              <a:lnSpc>
+                <a:spcPct val="105000"/>
+              </a:lnSpc>
+              <a:spcAft>
+                <a:spcPts val="400"/>
+              </a:spcAft>
+              <a:buClr>
+                <a:srgbClr val="088192"/>
+              </a:buClr>
+              <a:buFont typeface="Arial"/>
+              <a:buChar char="•"/>
+            </a:pPr>
+            <a:r>
+              <a:rPr sz="1500" b="0" i="0">
+                <a:solidFill>
+                  <a:srgbClr val="051218"/>
+                </a:solidFill>
+                <a:latin typeface="Calibri"/>
+              </a:rPr>
+              <a:t>Split each article into chunks, score each chunk, then average the scores.</a:t>
+            </a:r>
+          </a:p>
+          <a:p>
+            <a:pPr algn="l" marL="274320" indent="-274320">
+              <a:lnSpc>
+                <a:spcPct val="105000"/>
+              </a:lnSpc>
+              <a:spcAft>
+                <a:spcPts val="400"/>
+              </a:spcAft>
+              <a:buClr>
+                <a:srgbClr val="088192"/>
+              </a:buClr>
+              <a:buFont typeface="Arial"/>
+              <a:buChar char="•"/>
+            </a:pPr>
+            <a:r>
+              <a:rPr sz="1500" b="0" i="0">
+                <a:solidFill>
+                  <a:srgbClr val="051218"/>
+                </a:solidFill>
+                <a:latin typeface="Calibri"/>
+              </a:rPr>
+              <a:t>Bernoulli Naive Bayes changes only from 60.6% to 60.8%.</a:t>
+            </a:r>
+          </a:p>
+          <a:p>
+            <a:pPr algn="l" marL="274320" indent="-274320">
+              <a:lnSpc>
+                <a:spcPct val="105000"/>
+              </a:lnSpc>
+              <a:spcAft>
+                <a:spcPts val="400"/>
+              </a:spcAft>
+              <a:buClr>
+                <a:srgbClr val="088192"/>
+              </a:buClr>
+              <a:buFont typeface="Arial"/>
+              <a:buChar char="•"/>
+            </a:pPr>
+            <a:r>
+              <a:rPr sz="1500" b="0" i="0">
+                <a:solidFill>
+                  <a:srgbClr val="051218"/>
+                </a:solidFill>
+                <a:latin typeface="Calibri"/>
+              </a:rPr>
+              <a:t>LinearSVC falls from 58.4% to 51.8%.</a:t>
+            </a:r>
+          </a:p>
+          <a:p>
+            <a:pPr algn="l" marL="274320" indent="-274320">
+              <a:lnSpc>
+                <a:spcPct val="105000"/>
+              </a:lnSpc>
+              <a:spcAft>
+                <a:spcPts val="400"/>
+              </a:spcAft>
+              <a:buClr>
+                <a:srgbClr val="088192"/>
+              </a:buClr>
+              <a:buFont typeface="Arial"/>
+              <a:buChar char="•"/>
+            </a:pPr>
+            <a:r>
+              <a:rPr sz="1500" b="0" i="0">
+                <a:solidFill>
+                  <a:srgbClr val="051218"/>
+                </a:solidFill>
+                <a:latin typeface="Calibri"/>
+              </a:rPr>
+              <a:t>Chunking does not reliably close the tweet-to-news gap.</a:t>
+            </a:r>
+          </a:p>
+        </p:txBody>
+      </p:sp>
+      <p:sp>
+        <p:nvSpPr>
+          <p:cNvPr id="7" name="Footer band"/>
+          <p:cNvSpPr/>
+          <p:nvPr/>
+        </p:nvSpPr>
+        <p:spPr>
+          <a:xfrm>
+            <a:off x="0" y="6355080"/>
+            <a:ext cx="12191695" cy="502920"/>
+          </a:xfrm>
+          <a:prstGeom prst="rect">
+            <a:avLst/>
+          </a:prstGeom>
+          <a:solidFill>
+            <a:srgbClr val="053944"/>
+          </a:solidFill>
+          <a:ln>
+            <a:noFill/>
+          </a:ln>
+          <a:effectLst/>
+        </p:spPr>
+        <p:style>
+          <a:lnRef idx="1">
+            <a:schemeClr val="accent1"/>
+          </a:lnRef>
+          <a:fillRef idx="3">
+            <a:schemeClr val="accent1"/>
+          </a:fillRef>
+          <a:effectRef idx="2">
+            <a:schemeClr val="accent1"/>
+          </a:effectRef>
+          <a:fontRef idx="minor">
+            <a:schemeClr val="lt1"/>
+          </a:fontRef>
+        </p:style>
+        <p:txBody>
+          <a:bodyPr rtlCol="0" anchor="ctr"/>
+          <a:lstStyle/>
+          <a:p>
+            <a:pPr algn="ctr"/>
+          </a:p>
+        </p:txBody>
+      </p:sp>
+      <p:sp>
+        <p:nvSpPr>
+          <p:cNvPr id="8" name="Footer section"/>
+          <p:cNvSpPr txBox="1"/>
+          <p:nvPr/>
+        </p:nvSpPr>
+        <p:spPr>
+          <a:xfrm>
+            <a:off x="548640" y="6355080"/>
+            <a:ext cx="7315200" cy="502920"/>
+          </a:xfrm>
+          <a:prstGeom prst="rect">
+            <a:avLst/>
+          </a:prstGeom>
+          <a:noFill/>
+        </p:spPr>
+        <p:txBody>
+          <a:bodyPr wrap="square" lIns="0" rIns="0" tIns="0" bIns="0" anchor="ctr">
+            <a:spAutoFit/>
+          </a:bodyPr>
+          <a:lstStyle/>
+          <a:p>
+            <a:pPr algn="l">
+              <a:spcAft>
+                <a:spcPts val="0"/>
+              </a:spcAft>
+            </a:pPr>
+            <a:r>
+              <a:rPr sz="1100" b="0" i="0" spc="200">
+                <a:solidFill>
+                  <a:srgbClr val="F2EFE6"/>
+                </a:solidFill>
+                <a:latin typeface="Calibri"/>
+              </a:rPr>
+              <a:t>EXTENSIONS</a:t>
+            </a:r>
+          </a:p>
+        </p:txBody>
+      </p:sp>
+      <p:sp>
+        <p:nvSpPr>
+          <p:cNvPr id="9" name="Slide number"/>
+          <p:cNvSpPr txBox="1"/>
+          <p:nvPr/>
+        </p:nvSpPr>
+        <p:spPr>
+          <a:xfrm>
+            <a:off x="9814255" y="6355080"/>
+            <a:ext cx="1828800" cy="502920"/>
+          </a:xfrm>
+          <a:prstGeom prst="rect">
+            <a:avLst/>
+          </a:prstGeom>
+          <a:noFill/>
+        </p:spPr>
+        <p:txBody>
+          <a:bodyPr wrap="square" lIns="0" rIns="0" tIns="0" bIns="0" anchor="ctr">
+            <a:spAutoFit/>
+          </a:bodyPr>
+          <a:lstStyle/>
+          <a:p>
+            <a:pPr algn="r">
+              <a:spcAft>
+                <a:spcPts val="0"/>
+              </a:spcAft>
+            </a:pPr>
+            <a:r>
+              <a:rPr sz="1100" b="1" i="0" spc="200">
+                <a:solidFill>
+                  <a:srgbClr val="BCAC79"/>
+                </a:solidFill>
+                <a:latin typeface="Calibri"/>
+              </a:rPr>
+              <a:t>12</a:t>
+            </a:r>
+          </a:p>
+        </p:txBody>
+      </p:sp>
+    </p:spTree>
+  </p:cSld>
+  <p:clrMapOvr>
+    <a:masterClrMapping/>
+  </p:clrMapOvr>
+</p:sld>
+</file>
+
+<file path=ppt/slides/slide13.xml><?xml version="1.0" encoding="utf-8"?>
+<p:sld xmlns:a="http://schemas.openxmlformats.org/drawingml/2006/main" xmlns:p="http://schemas.openxmlformats.org/presentationml/2006/main" xmlns:r="http://schemas.openxmlformats.org/officeDocument/2006/relationships">
+  <p:cSld>
+    <p:bg>
+      <p:bgPr>
+        <a:solidFill>
+          <a:srgbClr val="F2EFE6"/>
+        </a:solidFill>
+        <a:effectLst/>
+      </p:bgPr>
+    </p:bg>
+    <p:spTree>
+      <p:nvGrpSpPr>
+        <p:cNvPr id="1" name=""/>
+        <p:cNvGrpSpPr/>
+        <p:nvPr/>
+      </p:nvGrpSpPr>
+      <p:grpSpPr/>
+      <p:sp>
+        <p:nvSpPr>
+          <p:cNvPr id="2" name="Title"/>
+          <p:cNvSpPr txBox="1"/>
+          <p:nvPr/>
+        </p:nvSpPr>
+        <p:spPr>
+          <a:xfrm>
+            <a:off x="548640" y="411480"/>
+            <a:ext cx="11094415" cy="548640"/>
+          </a:xfrm>
+          <a:prstGeom prst="rect">
+            <a:avLst/>
+          </a:prstGeom>
+          <a:noFill/>
+        </p:spPr>
+        <p:txBody>
+          <a:bodyPr wrap="square" lIns="0" rIns="0" tIns="0" bIns="0" anchor="ctr">
+            <a:spAutoFit/>
+          </a:bodyPr>
+          <a:lstStyle/>
+          <a:p>
+            <a:r>
+              <a:rPr sz="2600" b="1" i="0" spc="400">
+                <a:solidFill>
+                  <a:srgbClr val="051218"/>
+                </a:solidFill>
+                <a:latin typeface="Georgia"/>
+              </a:rPr>
+              <a:t>EXTENSION</a:t>
+            </a:r>
+            <a:r>
+              <a:rPr sz="2600" b="0" i="0" spc="400">
+                <a:solidFill>
+                  <a:srgbClr val="051218"/>
+                </a:solidFill>
+                <a:latin typeface="Georgia"/>
+              </a:rPr>
+              <a:t> 3: TRAIN ON ARTICLES</a:t>
+            </a:r>
+          </a:p>
+        </p:txBody>
+      </p:sp>
+      <p:pic>
+        <p:nvPicPr>
+          <p:cNvPr id="3" name="Figure ext3_in_domain" descr="ext3_in_domain.png"/>
+          <p:cNvPicPr>
+            <a:picLocks noChangeAspect="1"/>
+          </p:cNvPicPr>
+          <p:nvPr/>
+        </p:nvPicPr>
+        <p:blipFill>
+          <a:blip r:embed="rId2"/>
+          <a:stretch>
+            <a:fillRect/>
+          </a:stretch>
+        </p:blipFill>
+        <p:spPr>
+          <a:xfrm>
+            <a:off x="1852460" y="1097280"/>
+            <a:ext cx="8486775" cy="3703320"/>
+          </a:xfrm>
+          <a:prstGeom prst="rect">
+            <a:avLst/>
+          </a:prstGeom>
+        </p:spPr>
+      </p:pic>
+      <p:sp>
+        <p:nvSpPr>
+          <p:cNvPr id="4" name="Number 1 block"/>
+          <p:cNvSpPr/>
+          <p:nvPr/>
+        </p:nvSpPr>
+        <p:spPr>
+          <a:xfrm>
+            <a:off x="548640" y="5074920"/>
+            <a:ext cx="3931920" cy="960120"/>
+          </a:xfrm>
+          <a:prstGeom prst="roundRect">
+            <a:avLst>
+              <a:gd name="adj" fmla="val 10000"/>
+            </a:avLst>
+          </a:prstGeom>
+          <a:solidFill>
+            <a:srgbClr val="053944"/>
+          </a:solidFill>
+          <a:ln>
+            <a:noFill/>
+          </a:ln>
+          <a:effectLst/>
+        </p:spPr>
+        <p:style>
+          <a:lnRef idx="1">
+            <a:schemeClr val="accent1"/>
+          </a:lnRef>
+          <a:fillRef idx="3">
+            <a:schemeClr val="accent1"/>
+          </a:fillRef>
+          <a:effectRef idx="2">
+            <a:schemeClr val="accent1"/>
+          </a:effectRef>
+          <a:fontRef idx="minor">
+            <a:schemeClr val="lt1"/>
+          </a:fontRef>
+        </p:style>
+        <p:txBody>
+          <a:bodyPr rtlCol="0" anchor="ctr"/>
+          <a:lstStyle/>
+          <a:p>
+            <a:pPr algn="ctr"/>
+          </a:p>
+        </p:txBody>
+      </p:sp>
+      <p:sp>
+        <p:nvSpPr>
+          <p:cNvPr id="5" name="Number 1 text"/>
+          <p:cNvSpPr txBox="1"/>
+          <p:nvPr/>
+        </p:nvSpPr>
+        <p:spPr>
+          <a:xfrm>
+            <a:off x="777240" y="5257800"/>
+            <a:ext cx="3474720" cy="594360"/>
+          </a:xfrm>
+          <a:prstGeom prst="rect">
+            <a:avLst/>
+          </a:prstGeom>
+          <a:noFill/>
+        </p:spPr>
+        <p:txBody>
+          <a:bodyPr wrap="square" lIns="0" rIns="0" tIns="0" bIns="0" anchor="ctr">
+            <a:spAutoFit/>
+          </a:bodyPr>
+          <a:lstStyle/>
+          <a:p>
+            <a:pPr algn="l">
+              <a:spcAft>
+                <a:spcPts val="400"/>
+              </a:spcAft>
+            </a:pPr>
+            <a:r>
+              <a:rPr sz="2400" b="1" i="0">
+                <a:solidFill>
+                  <a:srgbClr val="BCAC79"/>
+                </a:solidFill>
+                <a:latin typeface="Calibri"/>
+              </a:rPr>
+              <a:t>+6.7 points</a:t>
+            </a:r>
+          </a:p>
+          <a:p>
+            <a:pPr algn="l">
+              <a:spcAft>
+                <a:spcPts val="0"/>
+              </a:spcAft>
+            </a:pPr>
+            <a:r>
+              <a:rPr sz="1400" b="0" i="0">
+                <a:solidFill>
+                  <a:srgbClr val="F2EFE6"/>
+                </a:solidFill>
+                <a:latin typeface="Calibri"/>
+              </a:rPr>
+              <a:t>over the always-Right baseline</a:t>
+            </a:r>
+          </a:p>
+        </p:txBody>
+      </p:sp>
+      <p:sp>
+        <p:nvSpPr>
+          <p:cNvPr id="6" name="Bullets"/>
+          <p:cNvSpPr txBox="1"/>
+          <p:nvPr/>
+        </p:nvSpPr>
+        <p:spPr>
+          <a:xfrm>
+            <a:off x="4937759" y="5074920"/>
+            <a:ext cx="6705295" cy="960120"/>
+          </a:xfrm>
+          <a:prstGeom prst="rect">
+            <a:avLst/>
+          </a:prstGeom>
+          <a:noFill/>
+        </p:spPr>
+        <p:txBody>
+          <a:bodyPr wrap="square" lIns="0" rIns="0" tIns="0" bIns="0" anchor="ctr">
+            <a:spAutoFit/>
+          </a:bodyPr>
+          <a:lstStyle/>
+          <a:p>
+            <a:pPr algn="l" marL="274320" indent="-274320">
+              <a:lnSpc>
+                <a:spcPct val="105000"/>
+              </a:lnSpc>
+              <a:spcAft>
+                <a:spcPts val="400"/>
+              </a:spcAft>
+              <a:buClr>
+                <a:srgbClr val="088192"/>
+              </a:buClr>
+              <a:buFont typeface="Arial"/>
+              <a:buChar char="•"/>
+            </a:pPr>
+            <a:r>
+              <a:rPr sz="1500" b="0" i="0">
+                <a:solidFill>
+                  <a:srgbClr val="051218"/>
+                </a:solidFill>
+                <a:latin typeface="Calibri"/>
+              </a:rPr>
+              <a:t>Train on 19,102 AllSides articles, then test on 1,001 unseen articles.</a:t>
+            </a:r>
+          </a:p>
+          <a:p>
+            <a:pPr algn="l" marL="274320" indent="-274320">
+              <a:lnSpc>
+                <a:spcPct val="105000"/>
+              </a:lnSpc>
+              <a:spcAft>
+                <a:spcPts val="400"/>
+              </a:spcAft>
+              <a:buClr>
+                <a:srgbClr val="088192"/>
+              </a:buClr>
+              <a:buFont typeface="Arial"/>
+              <a:buChar char="•"/>
+            </a:pPr>
+            <a:r>
+              <a:rPr sz="1500" b="0" i="0">
+                <a:solidFill>
+                  <a:srgbClr val="051218"/>
+                </a:solidFill>
+                <a:latin typeface="Calibri"/>
+              </a:rPr>
+              <a:t>LinearSVC reaches 66.5% accuracy and 65.8% macro F1.</a:t>
+            </a:r>
+          </a:p>
+          <a:p>
+            <a:pPr algn="l" marL="274320" indent="-274320">
+              <a:lnSpc>
+                <a:spcPct val="105000"/>
+              </a:lnSpc>
+              <a:spcAft>
+                <a:spcPts val="400"/>
+              </a:spcAft>
+              <a:buClr>
+                <a:srgbClr val="088192"/>
+              </a:buClr>
+              <a:buFont typeface="Arial"/>
+              <a:buChar char="•"/>
+            </a:pPr>
+            <a:r>
+              <a:rPr sz="1500" b="0" i="0">
+                <a:solidFill>
+                  <a:srgbClr val="051218"/>
+                </a:solidFill>
+                <a:latin typeface="Calibri"/>
+              </a:rPr>
+              <a:t>The three-class task is harder: the best model reaches 53.7%.</a:t>
+            </a:r>
+          </a:p>
+        </p:txBody>
+      </p:sp>
+      <p:sp>
+        <p:nvSpPr>
+          <p:cNvPr id="7" name="Footer band"/>
+          <p:cNvSpPr/>
+          <p:nvPr/>
+        </p:nvSpPr>
+        <p:spPr>
+          <a:xfrm>
+            <a:off x="0" y="6355080"/>
+            <a:ext cx="12191695" cy="502920"/>
+          </a:xfrm>
+          <a:prstGeom prst="rect">
+            <a:avLst/>
+          </a:prstGeom>
+          <a:solidFill>
+            <a:srgbClr val="053944"/>
+          </a:solidFill>
+          <a:ln>
+            <a:noFill/>
+          </a:ln>
+          <a:effectLst/>
+        </p:spPr>
+        <p:style>
+          <a:lnRef idx="1">
+            <a:schemeClr val="accent1"/>
+          </a:lnRef>
+          <a:fillRef idx="3">
+            <a:schemeClr val="accent1"/>
+          </a:fillRef>
+          <a:effectRef idx="2">
+            <a:schemeClr val="accent1"/>
+          </a:effectRef>
+          <a:fontRef idx="minor">
+            <a:schemeClr val="lt1"/>
+          </a:fontRef>
+        </p:style>
+        <p:txBody>
+          <a:bodyPr rtlCol="0" anchor="ctr"/>
+          <a:lstStyle/>
+          <a:p>
+            <a:pPr algn="ctr"/>
+          </a:p>
+        </p:txBody>
+      </p:sp>
+      <p:sp>
+        <p:nvSpPr>
+          <p:cNvPr id="8" name="Footer section"/>
+          <p:cNvSpPr txBox="1"/>
+          <p:nvPr/>
+        </p:nvSpPr>
+        <p:spPr>
+          <a:xfrm>
+            <a:off x="548640" y="6355080"/>
+            <a:ext cx="7315200" cy="502920"/>
+          </a:xfrm>
+          <a:prstGeom prst="rect">
+            <a:avLst/>
+          </a:prstGeom>
+          <a:noFill/>
+        </p:spPr>
+        <p:txBody>
+          <a:bodyPr wrap="square" lIns="0" rIns="0" tIns="0" bIns="0" anchor="ctr">
+            <a:spAutoFit/>
+          </a:bodyPr>
+          <a:lstStyle/>
+          <a:p>
+            <a:pPr algn="l">
+              <a:spcAft>
+                <a:spcPts val="0"/>
+              </a:spcAft>
+            </a:pPr>
+            <a:r>
+              <a:rPr sz="1100" b="0" i="0" spc="200">
+                <a:solidFill>
+                  <a:srgbClr val="F2EFE6"/>
+                </a:solidFill>
+                <a:latin typeface="Calibri"/>
+              </a:rPr>
+              <a:t>EXTENSIONS</a:t>
+            </a:r>
+          </a:p>
+        </p:txBody>
+      </p:sp>
+      <p:sp>
+        <p:nvSpPr>
+          <p:cNvPr id="9" name="Slide number"/>
+          <p:cNvSpPr txBox="1"/>
+          <p:nvPr/>
+        </p:nvSpPr>
+        <p:spPr>
+          <a:xfrm>
+            <a:off x="9814255" y="6355080"/>
+            <a:ext cx="1828800" cy="502920"/>
+          </a:xfrm>
+          <a:prstGeom prst="rect">
+            <a:avLst/>
+          </a:prstGeom>
+          <a:noFill/>
+        </p:spPr>
+        <p:txBody>
+          <a:bodyPr wrap="square" lIns="0" rIns="0" tIns="0" bIns="0" anchor="ctr">
+            <a:spAutoFit/>
+          </a:bodyPr>
+          <a:lstStyle/>
+          <a:p>
+            <a:pPr algn="r">
+              <a:spcAft>
+                <a:spcPts val="0"/>
+              </a:spcAft>
+            </a:pPr>
+            <a:r>
+              <a:rPr sz="1100" b="1" i="0" spc="200">
+                <a:solidFill>
+                  <a:srgbClr val="BCAC79"/>
+                </a:solidFill>
+                <a:latin typeface="Calibri"/>
+              </a:rPr>
+              <a:t>13</a:t>
+            </a:r>
+          </a:p>
+        </p:txBody>
+      </p:sp>
+    </p:spTree>
+  </p:cSld>
+  <p:clrMapOvr>
+    <a:masterClrMapping/>
+  </p:clrMapOvr>
+</p:sld>
+</file>
+
+<file path=ppt/slides/slide14.xml><?xml version="1.0" encoding="utf-8"?>
+<p:sld xmlns:a="http://schemas.openxmlformats.org/drawingml/2006/main" xmlns:p="http://schemas.openxmlformats.org/presentationml/2006/main" xmlns:r="http://schemas.openxmlformats.org/officeDocument/2006/relationships">
+  <p:cSld>
+    <p:bg>
+      <p:bgPr>
+        <a:solidFill>
+          <a:srgbClr val="F2EFE6"/>
+        </a:solidFill>
+        <a:effectLst/>
+      </p:bgPr>
+    </p:bg>
+    <p:spTree>
+      <p:nvGrpSpPr>
+        <p:cNvPr id="1" name=""/>
+        <p:cNvGrpSpPr/>
+        <p:nvPr/>
+      </p:nvGrpSpPr>
+      <p:grpSpPr/>
+      <p:sp>
+        <p:nvSpPr>
+          <p:cNvPr id="2" name="Title"/>
+          <p:cNvSpPr txBox="1"/>
+          <p:nvPr/>
+        </p:nvSpPr>
+        <p:spPr>
+          <a:xfrm>
+            <a:off x="548640" y="411480"/>
+            <a:ext cx="11094415" cy="548640"/>
+          </a:xfrm>
+          <a:prstGeom prst="rect">
+            <a:avLst/>
+          </a:prstGeom>
+          <a:noFill/>
+        </p:spPr>
+        <p:txBody>
+          <a:bodyPr wrap="square" lIns="0" rIns="0" tIns="0" bIns="0" anchor="ctr">
+            <a:spAutoFit/>
+          </a:bodyPr>
+          <a:lstStyle/>
+          <a:p>
+            <a:r>
+              <a:rPr sz="2600" b="1" i="0" spc="400">
+                <a:solidFill>
+                  <a:srgbClr val="051218"/>
+                </a:solidFill>
+                <a:latin typeface="Georgia"/>
+              </a:rPr>
+              <a:t>LIVE</a:t>
+            </a:r>
+            <a:r>
+              <a:rPr sz="2600" b="0" i="0" spc="400">
+                <a:solidFill>
+                  <a:srgbClr val="051218"/>
+                </a:solidFill>
+                <a:latin typeface="Georgia"/>
+              </a:rPr>
+              <a:t> DEMO: THREE STEPS</a:t>
+            </a:r>
+          </a:p>
+        </p:txBody>
+      </p:sp>
+      <p:sp>
+        <p:nvSpPr>
+          <p:cNvPr id="3" name="Step 1 block"/>
+          <p:cNvSpPr/>
+          <p:nvPr/>
+        </p:nvSpPr>
+        <p:spPr>
+          <a:xfrm>
+            <a:off x="548640" y="1943100"/>
+            <a:ext cx="3515258" cy="2103120"/>
+          </a:xfrm>
+          <a:prstGeom prst="roundRect">
+            <a:avLst>
+              <a:gd name="adj" fmla="val 18000"/>
+            </a:avLst>
+          </a:prstGeom>
+          <a:solidFill>
+            <a:srgbClr val="088192"/>
+          </a:solidFill>
+          <a:ln>
+            <a:noFill/>
+          </a:ln>
+          <a:effectLst/>
+        </p:spPr>
+        <p:style>
+          <a:lnRef idx="1">
+            <a:schemeClr val="accent1"/>
+          </a:lnRef>
+          <a:fillRef idx="3">
+            <a:schemeClr val="accent1"/>
+          </a:fillRef>
+          <a:effectRef idx="2">
+            <a:schemeClr val="accent1"/>
+          </a:effectRef>
+          <a:fontRef idx="minor">
+            <a:schemeClr val="lt1"/>
+          </a:fontRef>
+        </p:style>
+        <p:txBody>
+          <a:bodyPr rtlCol="0" anchor="ctr"/>
+          <a:lstStyle/>
+          <a:p>
+            <a:pPr algn="ctr"/>
+          </a:p>
+        </p:txBody>
+      </p:sp>
+      <p:sp>
+        <p:nvSpPr>
+          <p:cNvPr id="4" name="Step 1 label"/>
+          <p:cNvSpPr txBox="1"/>
+          <p:nvPr/>
+        </p:nvSpPr>
+        <p:spPr>
+          <a:xfrm>
+            <a:off x="868680" y="2217420"/>
+            <a:ext cx="2875178" cy="1554479"/>
+          </a:xfrm>
+          <a:prstGeom prst="rect">
+            <a:avLst/>
+          </a:prstGeom>
+          <a:noFill/>
+        </p:spPr>
+        <p:txBody>
+          <a:bodyPr wrap="square" lIns="0" rIns="0" tIns="0" bIns="0" anchor="b">
+            <a:spAutoFit/>
+          </a:bodyPr>
+          <a:lstStyle/>
+          <a:p>
+            <a:pPr algn="l">
+              <a:spcAft>
+                <a:spcPts val="200"/>
+              </a:spcAft>
+            </a:pPr>
+            <a:r>
+              <a:rPr sz="4400" b="1" i="0">
+                <a:solidFill>
+                  <a:srgbClr val="BCAC79"/>
+                </a:solidFill>
+                <a:latin typeface="Calibri"/>
+              </a:rPr>
+              <a:t>01</a:t>
+            </a:r>
+          </a:p>
+          <a:p>
+            <a:pPr algn="l">
+              <a:spcAft>
+                <a:spcPts val="0"/>
+              </a:spcAft>
+            </a:pPr>
+            <a:r>
+              <a:rPr sz="1500" b="1" i="0" spc="200">
+                <a:solidFill>
+                  <a:srgbClr val="F2EFE6"/>
+                </a:solidFill>
+                <a:latin typeface="Calibri"/>
+              </a:rPr>
+              <a:t>1. EASY CORRECT CASE</a:t>
+            </a:r>
+          </a:p>
+        </p:txBody>
+      </p:sp>
+      <p:sp>
+        <p:nvSpPr>
+          <p:cNvPr id="5" name="Step 1 text"/>
+          <p:cNvSpPr txBox="1"/>
+          <p:nvPr/>
+        </p:nvSpPr>
+        <p:spPr>
+          <a:xfrm>
+            <a:off x="594360" y="4320540"/>
+            <a:ext cx="3423818" cy="1097280"/>
+          </a:xfrm>
+          <a:prstGeom prst="rect">
+            <a:avLst/>
+          </a:prstGeom>
+          <a:noFill/>
+        </p:spPr>
+        <p:txBody>
+          <a:bodyPr wrap="square" lIns="0" rIns="0" tIns="0" bIns="0" anchor="t">
+            <a:spAutoFit/>
+          </a:bodyPr>
+          <a:lstStyle/>
+          <a:p>
+            <a:pPr algn="l">
+              <a:spcAft>
+                <a:spcPts val="0"/>
+              </a:spcAft>
+            </a:pPr>
+            <a:r>
+              <a:rPr sz="1700" b="0" i="0">
+                <a:solidFill>
+                  <a:srgbClr val="051218"/>
+                </a:solidFill>
+                <a:latin typeface="Calibri"/>
+              </a:rPr>
+              <a:t>Score the Breitbart article with the article-trained model.</a:t>
+            </a:r>
+          </a:p>
+        </p:txBody>
+      </p:sp>
+      <p:sp>
+        <p:nvSpPr>
+          <p:cNvPr id="6" name="Step 2 block"/>
+          <p:cNvSpPr/>
+          <p:nvPr/>
+        </p:nvSpPr>
+        <p:spPr>
+          <a:xfrm>
+            <a:off x="4338218" y="1943100"/>
+            <a:ext cx="3515258" cy="2103120"/>
+          </a:xfrm>
+          <a:prstGeom prst="roundRect">
+            <a:avLst>
+              <a:gd name="adj" fmla="val 18000"/>
+            </a:avLst>
+          </a:prstGeom>
+          <a:solidFill>
+            <a:srgbClr val="0A5C68"/>
+          </a:solidFill>
+          <a:ln>
+            <a:noFill/>
+          </a:ln>
+          <a:effectLst/>
+        </p:spPr>
+        <p:style>
+          <a:lnRef idx="1">
+            <a:schemeClr val="accent1"/>
+          </a:lnRef>
+          <a:fillRef idx="3">
+            <a:schemeClr val="accent1"/>
+          </a:fillRef>
+          <a:effectRef idx="2">
+            <a:schemeClr val="accent1"/>
+          </a:effectRef>
+          <a:fontRef idx="minor">
+            <a:schemeClr val="lt1"/>
+          </a:fontRef>
+        </p:style>
+        <p:txBody>
+          <a:bodyPr rtlCol="0" anchor="ctr"/>
+          <a:lstStyle/>
+          <a:p>
+            <a:pPr algn="ctr"/>
+          </a:p>
+        </p:txBody>
+      </p:sp>
+      <p:sp>
+        <p:nvSpPr>
+          <p:cNvPr id="7" name="Step 2 label"/>
+          <p:cNvSpPr txBox="1"/>
+          <p:nvPr/>
+        </p:nvSpPr>
+        <p:spPr>
+          <a:xfrm>
+            <a:off x="4658258" y="2217420"/>
+            <a:ext cx="2875178" cy="1554479"/>
+          </a:xfrm>
+          <a:prstGeom prst="rect">
+            <a:avLst/>
+          </a:prstGeom>
+          <a:noFill/>
+        </p:spPr>
+        <p:txBody>
+          <a:bodyPr wrap="square" lIns="0" rIns="0" tIns="0" bIns="0" anchor="b">
+            <a:spAutoFit/>
+          </a:bodyPr>
+          <a:lstStyle/>
+          <a:p>
+            <a:pPr algn="l">
+              <a:spcAft>
+                <a:spcPts val="200"/>
+              </a:spcAft>
+            </a:pPr>
+            <a:r>
+              <a:rPr sz="4400" b="1" i="0">
+                <a:solidFill>
+                  <a:srgbClr val="BCAC79"/>
+                </a:solidFill>
+                <a:latin typeface="Calibri"/>
+              </a:rPr>
+              <a:t>02</a:t>
+            </a:r>
+          </a:p>
+          <a:p>
+            <a:pPr algn="l">
+              <a:spcAft>
+                <a:spcPts val="0"/>
+              </a:spcAft>
+            </a:pPr>
+            <a:r>
+              <a:rPr sz="1500" b="1" i="0" spc="200">
+                <a:solidFill>
+                  <a:srgbClr val="F2EFE6"/>
+                </a:solidFill>
+                <a:latin typeface="Calibri"/>
+              </a:rPr>
+              <a:t>2. SHOW A FAILURE</a:t>
+            </a:r>
+          </a:p>
+        </p:txBody>
+      </p:sp>
+      <p:sp>
+        <p:nvSpPr>
+          <p:cNvPr id="8" name="Step 2 text"/>
+          <p:cNvSpPr txBox="1"/>
+          <p:nvPr/>
+        </p:nvSpPr>
+        <p:spPr>
+          <a:xfrm>
+            <a:off x="4383938" y="4320540"/>
+            <a:ext cx="3423818" cy="1097280"/>
+          </a:xfrm>
+          <a:prstGeom prst="rect">
+            <a:avLst/>
+          </a:prstGeom>
+          <a:noFill/>
+        </p:spPr>
+        <p:txBody>
+          <a:bodyPr wrap="square" lIns="0" rIns="0" tIns="0" bIns="0" anchor="t">
+            <a:spAutoFit/>
+          </a:bodyPr>
+          <a:lstStyle/>
+          <a:p>
+            <a:pPr algn="l">
+              <a:spcAft>
+                <a:spcPts val="0"/>
+              </a:spcAft>
+            </a:pPr>
+            <a:r>
+              <a:rPr sz="1700" b="0" i="0">
+                <a:solidFill>
+                  <a:srgbClr val="051218"/>
+                </a:solidFill>
+                <a:latin typeface="Calibri"/>
+              </a:rPr>
+              <a:t>Use the CNN article, then switch to the tweet SVM for comparison.</a:t>
+            </a:r>
+          </a:p>
+        </p:txBody>
+      </p:sp>
+      <p:sp>
+        <p:nvSpPr>
+          <p:cNvPr id="9" name="Step 3 block"/>
+          <p:cNvSpPr/>
+          <p:nvPr/>
+        </p:nvSpPr>
+        <p:spPr>
+          <a:xfrm>
+            <a:off x="8127796" y="1943100"/>
+            <a:ext cx="3515258" cy="2103120"/>
+          </a:xfrm>
+          <a:prstGeom prst="roundRect">
+            <a:avLst>
+              <a:gd name="adj" fmla="val 18000"/>
+            </a:avLst>
+          </a:prstGeom>
+          <a:solidFill>
+            <a:srgbClr val="053944"/>
+          </a:solidFill>
+          <a:ln>
+            <a:noFill/>
+          </a:ln>
+          <a:effectLst/>
+        </p:spPr>
+        <p:style>
+          <a:lnRef idx="1">
+            <a:schemeClr val="accent1"/>
+          </a:lnRef>
+          <a:fillRef idx="3">
+            <a:schemeClr val="accent1"/>
+          </a:fillRef>
+          <a:effectRef idx="2">
+            <a:schemeClr val="accent1"/>
+          </a:effectRef>
+          <a:fontRef idx="minor">
+            <a:schemeClr val="lt1"/>
+          </a:fontRef>
+        </p:style>
+        <p:txBody>
+          <a:bodyPr rtlCol="0" anchor="ctr"/>
+          <a:lstStyle/>
+          <a:p>
+            <a:pPr algn="ctr"/>
+          </a:p>
+        </p:txBody>
+      </p:sp>
+      <p:sp>
+        <p:nvSpPr>
+          <p:cNvPr id="10" name="Step 3 label"/>
+          <p:cNvSpPr txBox="1"/>
+          <p:nvPr/>
+        </p:nvSpPr>
+        <p:spPr>
+          <a:xfrm>
+            <a:off x="8447836" y="2217420"/>
+            <a:ext cx="2875178" cy="1554479"/>
+          </a:xfrm>
+          <a:prstGeom prst="rect">
+            <a:avLst/>
+          </a:prstGeom>
+          <a:noFill/>
+        </p:spPr>
+        <p:txBody>
+          <a:bodyPr wrap="square" lIns="0" rIns="0" tIns="0" bIns="0" anchor="b">
+            <a:spAutoFit/>
+          </a:bodyPr>
+          <a:lstStyle/>
+          <a:p>
+            <a:pPr algn="l">
+              <a:spcAft>
+                <a:spcPts val="200"/>
+              </a:spcAft>
+            </a:pPr>
+            <a:r>
+              <a:rPr sz="4400" b="1" i="0">
+                <a:solidFill>
+                  <a:srgbClr val="BCAC79"/>
+                </a:solidFill>
+                <a:latin typeface="Calibri"/>
+              </a:rPr>
+              <a:t>03</a:t>
+            </a:r>
+          </a:p>
+          <a:p>
+            <a:pPr algn="l">
+              <a:spcAft>
+                <a:spcPts val="0"/>
+              </a:spcAft>
+            </a:pPr>
+            <a:r>
+              <a:rPr sz="1500" b="1" i="0" spc="200">
+                <a:solidFill>
+                  <a:srgbClr val="F2EFE6"/>
+                </a:solidFill>
+                <a:latin typeface="Calibri"/>
+              </a:rPr>
+              <a:t>3. PASTE A SENTENCE</a:t>
+            </a:r>
+          </a:p>
+        </p:txBody>
+      </p:sp>
+      <p:sp>
+        <p:nvSpPr>
+          <p:cNvPr id="11" name="Step 3 text"/>
+          <p:cNvSpPr txBox="1"/>
+          <p:nvPr/>
+        </p:nvSpPr>
+        <p:spPr>
+          <a:xfrm>
+            <a:off x="8173516" y="4320540"/>
+            <a:ext cx="3423818" cy="1097280"/>
+          </a:xfrm>
+          <a:prstGeom prst="rect">
+            <a:avLst/>
+          </a:prstGeom>
+          <a:noFill/>
+        </p:spPr>
+        <p:txBody>
+          <a:bodyPr wrap="square" lIns="0" rIns="0" tIns="0" bIns="0" anchor="t">
+            <a:spAutoFit/>
+          </a:bodyPr>
+          <a:lstStyle/>
+          <a:p>
+            <a:pPr algn="l">
+              <a:spcAft>
+                <a:spcPts val="0"/>
+              </a:spcAft>
+            </a:pPr>
+            <a:r>
+              <a:rPr sz="1700" b="0" i="0">
+                <a:solidFill>
+                  <a:srgbClr val="051218"/>
+                </a:solidFill>
+                <a:latin typeface="Calibri"/>
+              </a:rPr>
+              <a:t>Show the uncertain free-text result. The CLI is ready as a fallback.</a:t>
+            </a:r>
+          </a:p>
+        </p:txBody>
+      </p:sp>
+      <p:sp>
+        <p:nvSpPr>
+          <p:cNvPr id="12" name="Footer band"/>
+          <p:cNvSpPr/>
+          <p:nvPr/>
+        </p:nvSpPr>
+        <p:spPr>
+          <a:xfrm>
+            <a:off x="0" y="6355080"/>
+            <a:ext cx="12191695" cy="502920"/>
+          </a:xfrm>
+          <a:prstGeom prst="rect">
+            <a:avLst/>
+          </a:prstGeom>
+          <a:solidFill>
+            <a:srgbClr val="053944"/>
+          </a:solidFill>
+          <a:ln>
+            <a:noFill/>
+          </a:ln>
+          <a:effectLst/>
+        </p:spPr>
+        <p:style>
+          <a:lnRef idx="1">
+            <a:schemeClr val="accent1"/>
+          </a:lnRef>
+          <a:fillRef idx="3">
+            <a:schemeClr val="accent1"/>
+          </a:fillRef>
+          <a:effectRef idx="2">
+            <a:schemeClr val="accent1"/>
+          </a:effectRef>
+          <a:fontRef idx="minor">
+            <a:schemeClr val="lt1"/>
+          </a:fontRef>
+        </p:style>
+        <p:txBody>
+          <a:bodyPr rtlCol="0" anchor="ctr"/>
+          <a:lstStyle/>
+          <a:p>
+            <a:pPr algn="ctr"/>
+          </a:p>
+        </p:txBody>
+      </p:sp>
+      <p:sp>
+        <p:nvSpPr>
+          <p:cNvPr id="13" name="Footer section"/>
+          <p:cNvSpPr txBox="1"/>
+          <p:nvPr/>
+        </p:nvSpPr>
+        <p:spPr>
+          <a:xfrm>
+            <a:off x="548640" y="6355080"/>
+            <a:ext cx="7315200" cy="502920"/>
+          </a:xfrm>
+          <a:prstGeom prst="rect">
+            <a:avLst/>
+          </a:prstGeom>
+          <a:noFill/>
+        </p:spPr>
+        <p:txBody>
+          <a:bodyPr wrap="square" lIns="0" rIns="0" tIns="0" bIns="0" anchor="ctr">
+            <a:spAutoFit/>
+          </a:bodyPr>
+          <a:lstStyle/>
+          <a:p>
+            <a:pPr algn="l">
+              <a:spcAft>
+                <a:spcPts val="0"/>
+              </a:spcAft>
+            </a:pPr>
+            <a:r>
+              <a:rPr sz="1100" b="0" i="0" spc="200">
+                <a:solidFill>
+                  <a:srgbClr val="F2EFE6"/>
+                </a:solidFill>
+                <a:latin typeface="Calibri"/>
+              </a:rPr>
+              <a:t>DEMO</a:t>
+            </a:r>
+          </a:p>
+        </p:txBody>
+      </p:sp>
+      <p:sp>
+        <p:nvSpPr>
+          <p:cNvPr id="14" name="Slide number"/>
+          <p:cNvSpPr txBox="1"/>
+          <p:nvPr/>
+        </p:nvSpPr>
+        <p:spPr>
+          <a:xfrm>
+            <a:off x="9814255" y="6355080"/>
+            <a:ext cx="1828800" cy="502920"/>
+          </a:xfrm>
+          <a:prstGeom prst="rect">
+            <a:avLst/>
+          </a:prstGeom>
+          <a:noFill/>
+        </p:spPr>
+        <p:txBody>
+          <a:bodyPr wrap="square" lIns="0" rIns="0" tIns="0" bIns="0" anchor="ctr">
+            <a:spAutoFit/>
+          </a:bodyPr>
+          <a:lstStyle/>
+          <a:p>
+            <a:pPr algn="r">
+              <a:spcAft>
+                <a:spcPts val="0"/>
+              </a:spcAft>
+            </a:pPr>
+            <a:r>
+              <a:rPr sz="1100" b="1" i="0" spc="200">
+                <a:solidFill>
+                  <a:srgbClr val="BCAC79"/>
+                </a:solidFill>
+                <a:latin typeface="Calibri"/>
+              </a:rPr>
+              <a:t>14</a:t>
+            </a:r>
+          </a:p>
+        </p:txBody>
+      </p:sp>
+    </p:spTree>
+  </p:cSld>
+  <p:clrMapOvr>
+    <a:masterClrMapping/>
+  </p:clrMapOvr>
+</p:sld>
+</file>
+
+<file path=ppt/slides/slide15.xml><?xml version="1.0" encoding="utf-8"?>
+<p:sld xmlns:a="http://schemas.openxmlformats.org/drawingml/2006/main" xmlns:p="http://schemas.openxmlformats.org/presentationml/2006/main" xmlns:r="http://schemas.openxmlformats.org/officeDocument/2006/relationships">
+  <p:cSld>
+    <p:bg>
+      <p:bgPr>
+        <a:solidFill>
+          <a:srgbClr val="F2EFE6"/>
+        </a:solidFill>
+        <a:effectLst/>
+      </p:bgPr>
+    </p:bg>
+    <p:spTree>
+      <p:nvGrpSpPr>
+        <p:cNvPr id="1" name=""/>
+        <p:cNvGrpSpPr/>
+        <p:nvPr/>
+      </p:nvGrpSpPr>
+      <p:grpSpPr/>
+      <p:sp>
+        <p:nvSpPr>
+          <p:cNvPr id="2" name="Title"/>
+          <p:cNvSpPr txBox="1"/>
+          <p:nvPr/>
+        </p:nvSpPr>
+        <p:spPr>
+          <a:xfrm>
+            <a:off x="548640" y="411480"/>
+            <a:ext cx="11094415" cy="548640"/>
+          </a:xfrm>
+          <a:prstGeom prst="rect">
+            <a:avLst/>
+          </a:prstGeom>
+          <a:noFill/>
+        </p:spPr>
+        <p:txBody>
+          <a:bodyPr wrap="square" lIns="0" rIns="0" tIns="0" bIns="0" anchor="ctr">
+            <a:spAutoFit/>
+          </a:bodyPr>
+          <a:lstStyle/>
+          <a:p>
+            <a:r>
+              <a:rPr sz="2600" b="1" i="0" spc="400">
+                <a:solidFill>
+                  <a:srgbClr val="051218"/>
+                </a:solidFill>
+                <a:latin typeface="Georgia"/>
+              </a:rPr>
+              <a:t>RESULTS</a:t>
+            </a:r>
+            <a:r>
+              <a:rPr sz="2600" b="0" i="0" spc="400">
+                <a:solidFill>
+                  <a:srgbClr val="051218"/>
+                </a:solidFill>
+                <a:latin typeface="Georgia"/>
+              </a:rPr>
+              <a:t> AT A GLANCE</a:t>
+            </a:r>
+          </a:p>
+        </p:txBody>
+      </p:sp>
+      <p:sp>
+        <p:nvSpPr>
+          <p:cNvPr id="3" name="Number 1 block"/>
+          <p:cNvSpPr/>
+          <p:nvPr/>
+        </p:nvSpPr>
+        <p:spPr>
+          <a:xfrm>
+            <a:off x="548640" y="1325880"/>
+            <a:ext cx="3515258" cy="1600200"/>
+          </a:xfrm>
+          <a:prstGeom prst="roundRect">
+            <a:avLst>
+              <a:gd name="adj" fmla="val 10000"/>
+            </a:avLst>
+          </a:prstGeom>
+          <a:solidFill>
+            <a:srgbClr val="053944"/>
+          </a:solidFill>
+          <a:ln>
+            <a:noFill/>
+          </a:ln>
+          <a:effectLst/>
+        </p:spPr>
+        <p:style>
+          <a:lnRef idx="1">
+            <a:schemeClr val="accent1"/>
+          </a:lnRef>
+          <a:fillRef idx="3">
+            <a:schemeClr val="accent1"/>
+          </a:fillRef>
+          <a:effectRef idx="2">
+            <a:schemeClr val="accent1"/>
+          </a:effectRef>
+          <a:fontRef idx="minor">
+            <a:schemeClr val="lt1"/>
+          </a:fontRef>
+        </p:style>
+        <p:txBody>
+          <a:bodyPr rtlCol="0" anchor="ctr"/>
+          <a:lstStyle/>
+          <a:p>
+            <a:pPr algn="ctr"/>
+          </a:p>
+        </p:txBody>
+      </p:sp>
+      <p:sp>
+        <p:nvSpPr>
+          <p:cNvPr id="4" name="Number 1 text"/>
+          <p:cNvSpPr txBox="1"/>
+          <p:nvPr/>
+        </p:nvSpPr>
+        <p:spPr>
+          <a:xfrm>
+            <a:off x="777240" y="1508760"/>
+            <a:ext cx="3058058" cy="1234440"/>
+          </a:xfrm>
+          <a:prstGeom prst="rect">
+            <a:avLst/>
+          </a:prstGeom>
+          <a:noFill/>
+        </p:spPr>
+        <p:txBody>
+          <a:bodyPr wrap="square" lIns="0" rIns="0" tIns="0" bIns="0" anchor="ctr">
+            <a:spAutoFit/>
+          </a:bodyPr>
+          <a:lstStyle/>
+          <a:p>
+            <a:pPr algn="l">
+              <a:spcAft>
+                <a:spcPts val="400"/>
+              </a:spcAft>
+            </a:pPr>
+            <a:r>
+              <a:rPr sz="3600" b="1" i="0">
+                <a:solidFill>
+                  <a:srgbClr val="BCAC79"/>
+                </a:solidFill>
+                <a:latin typeface="Calibri"/>
+              </a:rPr>
+              <a:t>83.3%</a:t>
+            </a:r>
+          </a:p>
+          <a:p>
+            <a:pPr algn="l">
+              <a:spcAft>
+                <a:spcPts val="0"/>
+              </a:spcAft>
+            </a:pPr>
+            <a:r>
+              <a:rPr sz="1400" b="0" i="0">
+                <a:solidFill>
+                  <a:srgbClr val="F2EFE6"/>
+                </a:solidFill>
+                <a:latin typeface="Calibri"/>
+              </a:rPr>
+              <a:t>best tweet accuracy, Extension 1</a:t>
+            </a:r>
+          </a:p>
+        </p:txBody>
+      </p:sp>
+      <p:sp>
+        <p:nvSpPr>
+          <p:cNvPr id="5" name="Number 2 block"/>
+          <p:cNvSpPr/>
+          <p:nvPr/>
+        </p:nvSpPr>
+        <p:spPr>
+          <a:xfrm>
+            <a:off x="4338218" y="1325880"/>
+            <a:ext cx="3515258" cy="1600200"/>
+          </a:xfrm>
+          <a:prstGeom prst="roundRect">
+            <a:avLst>
+              <a:gd name="adj" fmla="val 10000"/>
+            </a:avLst>
+          </a:prstGeom>
+          <a:solidFill>
+            <a:srgbClr val="053944"/>
+          </a:solidFill>
+          <a:ln>
+            <a:noFill/>
+          </a:ln>
+          <a:effectLst/>
+        </p:spPr>
+        <p:style>
+          <a:lnRef idx="1">
+            <a:schemeClr val="accent1"/>
+          </a:lnRef>
+          <a:fillRef idx="3">
+            <a:schemeClr val="accent1"/>
+          </a:fillRef>
+          <a:effectRef idx="2">
+            <a:schemeClr val="accent1"/>
+          </a:effectRef>
+          <a:fontRef idx="minor">
+            <a:schemeClr val="lt1"/>
+          </a:fontRef>
+        </p:style>
+        <p:txBody>
+          <a:bodyPr rtlCol="0" anchor="ctr"/>
+          <a:lstStyle/>
+          <a:p>
+            <a:pPr algn="ctr"/>
+          </a:p>
+        </p:txBody>
+      </p:sp>
+      <p:sp>
+        <p:nvSpPr>
+          <p:cNvPr id="6" name="Number 2 text"/>
+          <p:cNvSpPr txBox="1"/>
+          <p:nvPr/>
+        </p:nvSpPr>
+        <p:spPr>
+          <a:xfrm>
+            <a:off x="4566818" y="1508760"/>
+            <a:ext cx="3058058" cy="1234440"/>
+          </a:xfrm>
+          <a:prstGeom prst="rect">
+            <a:avLst/>
+          </a:prstGeom>
+          <a:noFill/>
+        </p:spPr>
+        <p:txBody>
+          <a:bodyPr wrap="square" lIns="0" rIns="0" tIns="0" bIns="0" anchor="ctr">
+            <a:spAutoFit/>
+          </a:bodyPr>
+          <a:lstStyle/>
+          <a:p>
+            <a:pPr algn="l">
+              <a:spcAft>
+                <a:spcPts val="400"/>
+              </a:spcAft>
+            </a:pPr>
+            <a:r>
+              <a:rPr sz="3600" b="1" i="0">
+                <a:solidFill>
+                  <a:srgbClr val="BCAC79"/>
+                </a:solidFill>
+                <a:latin typeface="Calibri"/>
+              </a:rPr>
+              <a:t>66.5%</a:t>
+            </a:r>
+          </a:p>
+          <a:p>
+            <a:pPr algn="l">
+              <a:spcAft>
+                <a:spcPts val="0"/>
+              </a:spcAft>
+            </a:pPr>
+            <a:r>
+              <a:rPr sz="1400" b="0" i="0">
+                <a:solidFill>
+                  <a:srgbClr val="F2EFE6"/>
+                </a:solidFill>
+                <a:latin typeface="Calibri"/>
+              </a:rPr>
+              <a:t>best article accuracy, Extension 3</a:t>
+            </a:r>
+          </a:p>
+        </p:txBody>
+      </p:sp>
+      <p:sp>
+        <p:nvSpPr>
+          <p:cNvPr id="7" name="Number 3 block"/>
+          <p:cNvSpPr/>
+          <p:nvPr/>
+        </p:nvSpPr>
+        <p:spPr>
+          <a:xfrm>
+            <a:off x="8127796" y="1325880"/>
+            <a:ext cx="3515258" cy="1600200"/>
+          </a:xfrm>
+          <a:prstGeom prst="roundRect">
+            <a:avLst>
+              <a:gd name="adj" fmla="val 10000"/>
+            </a:avLst>
+          </a:prstGeom>
+          <a:solidFill>
+            <a:srgbClr val="053944"/>
+          </a:solidFill>
+          <a:ln>
+            <a:noFill/>
+          </a:ln>
+          <a:effectLst/>
+        </p:spPr>
+        <p:style>
+          <a:lnRef idx="1">
+            <a:schemeClr val="accent1"/>
+          </a:lnRef>
+          <a:fillRef idx="3">
+            <a:schemeClr val="accent1"/>
+          </a:fillRef>
+          <a:effectRef idx="2">
+            <a:schemeClr val="accent1"/>
+          </a:effectRef>
+          <a:fontRef idx="minor">
+            <a:schemeClr val="lt1"/>
+          </a:fontRef>
+        </p:style>
+        <p:txBody>
+          <a:bodyPr rtlCol="0" anchor="ctr"/>
+          <a:lstStyle/>
+          <a:p>
+            <a:pPr algn="ctr"/>
+          </a:p>
+        </p:txBody>
+      </p:sp>
+      <p:sp>
+        <p:nvSpPr>
+          <p:cNvPr id="8" name="Number 3 text"/>
+          <p:cNvSpPr txBox="1"/>
+          <p:nvPr/>
+        </p:nvSpPr>
+        <p:spPr>
+          <a:xfrm>
+            <a:off x="8356396" y="1508760"/>
+            <a:ext cx="3058058" cy="1234440"/>
+          </a:xfrm>
+          <a:prstGeom prst="rect">
+            <a:avLst/>
+          </a:prstGeom>
+          <a:noFill/>
+        </p:spPr>
+        <p:txBody>
+          <a:bodyPr wrap="square" lIns="0" rIns="0" tIns="0" bIns="0" anchor="ctr">
+            <a:spAutoFit/>
+          </a:bodyPr>
+          <a:lstStyle/>
+          <a:p>
+            <a:pPr algn="l">
+              <a:spcAft>
+                <a:spcPts val="400"/>
+              </a:spcAft>
+            </a:pPr>
+            <a:r>
+              <a:rPr sz="3600" b="1" i="0">
+                <a:solidFill>
+                  <a:srgbClr val="BCAC79"/>
+                </a:solidFill>
+                <a:latin typeface="Calibri"/>
+              </a:rPr>
+              <a:t>59.8%</a:t>
+            </a:r>
+          </a:p>
+          <a:p>
+            <a:pPr algn="l">
+              <a:spcAft>
+                <a:spcPts val="0"/>
+              </a:spcAft>
+            </a:pPr>
+            <a:r>
+              <a:rPr sz="1400" b="0" i="0">
+                <a:solidFill>
+                  <a:srgbClr val="F2EFE6"/>
+                </a:solidFill>
+                <a:latin typeface="Calibri"/>
+              </a:rPr>
+              <a:t>always-Right article baseline</a:t>
+            </a:r>
+          </a:p>
+        </p:txBody>
+      </p:sp>
+      <p:sp>
+        <p:nvSpPr>
+          <p:cNvPr id="9" name="Bullets"/>
+          <p:cNvSpPr txBox="1"/>
+          <p:nvPr/>
+        </p:nvSpPr>
+        <p:spPr>
+          <a:xfrm>
+            <a:off x="548640" y="3337560"/>
+            <a:ext cx="11094415" cy="2697480"/>
+          </a:xfrm>
+          <a:prstGeom prst="rect">
+            <a:avLst/>
+          </a:prstGeom>
+          <a:noFill/>
+        </p:spPr>
+        <p:txBody>
+          <a:bodyPr wrap="square" lIns="0" rIns="0" tIns="0" bIns="0" anchor="t">
+            <a:spAutoFit/>
+          </a:bodyPr>
+          <a:lstStyle/>
+          <a:p>
+            <a:pPr algn="l" marL="274320" indent="-274320">
+              <a:lnSpc>
+                <a:spcPct val="105000"/>
+              </a:lnSpc>
+              <a:spcAft>
+                <a:spcPts val="1400"/>
+              </a:spcAft>
+              <a:buClr>
+                <a:srgbClr val="088192"/>
+              </a:buClr>
+              <a:buFont typeface="Arial"/>
+              <a:buChar char="•"/>
+            </a:pPr>
+            <a:r>
+              <a:rPr sz="1800" b="0" i="0">
+                <a:solidFill>
+                  <a:srgbClr val="051218"/>
+                </a:solidFill>
+                <a:latin typeface="Calibri"/>
+              </a:rPr>
+              <a:t>Training and testing within the same domain gives the clearest improvement.</a:t>
+            </a:r>
+          </a:p>
+        </p:txBody>
+      </p:sp>
+      <p:sp>
+        <p:nvSpPr>
+          <p:cNvPr id="10" name="Footer band"/>
+          <p:cNvSpPr/>
+          <p:nvPr/>
+        </p:nvSpPr>
+        <p:spPr>
+          <a:xfrm>
+            <a:off x="0" y="6355080"/>
+            <a:ext cx="12191695" cy="502920"/>
+          </a:xfrm>
+          <a:prstGeom prst="rect">
+            <a:avLst/>
+          </a:prstGeom>
+          <a:solidFill>
+            <a:srgbClr val="053944"/>
+          </a:solidFill>
+          <a:ln>
+            <a:noFill/>
+          </a:ln>
+          <a:effectLst/>
+        </p:spPr>
+        <p:style>
+          <a:lnRef idx="1">
+            <a:schemeClr val="accent1"/>
+          </a:lnRef>
+          <a:fillRef idx="3">
+            <a:schemeClr val="accent1"/>
+          </a:fillRef>
+          <a:effectRef idx="2">
+            <a:schemeClr val="accent1"/>
+          </a:effectRef>
+          <a:fontRef idx="minor">
+            <a:schemeClr val="lt1"/>
+          </a:fontRef>
+        </p:style>
+        <p:txBody>
+          <a:bodyPr rtlCol="0" anchor="ctr"/>
+          <a:lstStyle/>
+          <a:p>
+            <a:pPr algn="ctr"/>
+          </a:p>
+        </p:txBody>
+      </p:sp>
+      <p:sp>
+        <p:nvSpPr>
+          <p:cNvPr id="11" name="Footer section"/>
+          <p:cNvSpPr txBox="1"/>
+          <p:nvPr/>
+        </p:nvSpPr>
+        <p:spPr>
+          <a:xfrm>
+            <a:off x="548640" y="6355080"/>
+            <a:ext cx="7315200" cy="502920"/>
+          </a:xfrm>
+          <a:prstGeom prst="rect">
+            <a:avLst/>
+          </a:prstGeom>
+          <a:noFill/>
+        </p:spPr>
+        <p:txBody>
+          <a:bodyPr wrap="square" lIns="0" rIns="0" tIns="0" bIns="0" anchor="ctr">
+            <a:spAutoFit/>
+          </a:bodyPr>
+          <a:lstStyle/>
+          <a:p>
+            <a:pPr algn="l">
+              <a:spcAft>
+                <a:spcPts val="0"/>
+              </a:spcAft>
+            </a:pPr>
+            <a:r>
+              <a:rPr sz="1100" b="0" i="0" spc="200">
+                <a:solidFill>
+                  <a:srgbClr val="F2EFE6"/>
+                </a:solidFill>
+                <a:latin typeface="Calibri"/>
+              </a:rPr>
+              <a:t>RESULTS</a:t>
+            </a:r>
+          </a:p>
+        </p:txBody>
+      </p:sp>
+      <p:sp>
+        <p:nvSpPr>
+          <p:cNvPr id="12" name="Slide number"/>
+          <p:cNvSpPr txBox="1"/>
+          <p:nvPr/>
+        </p:nvSpPr>
+        <p:spPr>
+          <a:xfrm>
+            <a:off x="9814255" y="6355080"/>
+            <a:ext cx="1828800" cy="502920"/>
+          </a:xfrm>
+          <a:prstGeom prst="rect">
+            <a:avLst/>
+          </a:prstGeom>
+          <a:noFill/>
+        </p:spPr>
+        <p:txBody>
+          <a:bodyPr wrap="square" lIns="0" rIns="0" tIns="0" bIns="0" anchor="ctr">
+            <a:spAutoFit/>
+          </a:bodyPr>
+          <a:lstStyle/>
+          <a:p>
+            <a:pPr algn="r">
+              <a:spcAft>
+                <a:spcPts val="0"/>
+              </a:spcAft>
+            </a:pPr>
+            <a:r>
+              <a:rPr sz="1100" b="1" i="0" spc="200">
+                <a:solidFill>
+                  <a:srgbClr val="BCAC79"/>
+                </a:solidFill>
+                <a:latin typeface="Calibri"/>
+              </a:rPr>
+              <a:t>15</a:t>
+            </a:r>
+          </a:p>
+        </p:txBody>
+      </p:sp>
+    </p:spTree>
+  </p:cSld>
+  <p:clrMapOvr>
+    <a:masterClrMapping/>
+  </p:clrMapOvr>
+</p:sld>
+</file>
+
+<file path=ppt/slides/slide16.xml><?xml version="1.0" encoding="utf-8"?>
+<p:sld xmlns:a="http://schemas.openxmlformats.org/drawingml/2006/main" xmlns:p="http://schemas.openxmlformats.org/presentationml/2006/main" xmlns:r="http://schemas.openxmlformats.org/officeDocument/2006/relationships">
+  <p:cSld>
+    <p:bg>
+      <p:bgPr>
+        <a:solidFill>
+          <a:srgbClr val="F2EFE6"/>
+        </a:solidFill>
+        <a:effectLst/>
+      </p:bgPr>
+    </p:bg>
+    <p:spTree>
+      <p:nvGrpSpPr>
+        <p:cNvPr id="1" name=""/>
+        <p:cNvGrpSpPr/>
+        <p:nvPr/>
+      </p:nvGrpSpPr>
+      <p:grpSpPr/>
+      <p:sp>
+        <p:nvSpPr>
+          <p:cNvPr id="2" name="Title"/>
+          <p:cNvSpPr txBox="1"/>
+          <p:nvPr/>
+        </p:nvSpPr>
+        <p:spPr>
+          <a:xfrm>
+            <a:off x="548640" y="411480"/>
+            <a:ext cx="11094415" cy="548640"/>
+          </a:xfrm>
+          <a:prstGeom prst="rect">
+            <a:avLst/>
+          </a:prstGeom>
+          <a:noFill/>
+        </p:spPr>
+        <p:txBody>
+          <a:bodyPr wrap="square" lIns="0" rIns="0" tIns="0" bIns="0" anchor="ctr">
+            <a:spAutoFit/>
+          </a:bodyPr>
+          <a:lstStyle/>
+          <a:p>
+            <a:r>
+              <a:rPr sz="2600" b="1" i="0" spc="400">
+                <a:solidFill>
+                  <a:srgbClr val="051218"/>
+                </a:solidFill>
+                <a:latin typeface="Georgia"/>
+              </a:rPr>
+              <a:t>LIMITATIONS</a:t>
+            </a:r>
+            <a:r>
+              <a:rPr sz="2600" b="0" i="0" spc="400">
+                <a:solidFill>
+                  <a:srgbClr val="051218"/>
+                </a:solidFill>
+                <a:latin typeface="Georgia"/>
+              </a:rPr>
+              <a:t> AND NEXT STEPS</a:t>
+            </a:r>
+          </a:p>
+        </p:txBody>
+      </p:sp>
+      <p:sp>
+        <p:nvSpPr>
+          <p:cNvPr id="3" name="Bullets"/>
+          <p:cNvSpPr txBox="1"/>
+          <p:nvPr/>
+        </p:nvSpPr>
+        <p:spPr>
+          <a:xfrm>
+            <a:off x="548640" y="1417320"/>
+            <a:ext cx="11094415" cy="4617720"/>
+          </a:xfrm>
+          <a:prstGeom prst="rect">
+            <a:avLst/>
+          </a:prstGeom>
+          <a:noFill/>
+        </p:spPr>
+        <p:txBody>
+          <a:bodyPr wrap="square" lIns="0" rIns="0" tIns="0" bIns="0" anchor="ctr">
+            <a:spAutoFit/>
+          </a:bodyPr>
+          <a:lstStyle/>
+          <a:p>
+            <a:pPr algn="l" marL="274320" indent="-274320">
+              <a:lnSpc>
+                <a:spcPct val="105000"/>
+              </a:lnSpc>
+              <a:spcAft>
+                <a:spcPts val="2000"/>
+              </a:spcAft>
+              <a:buClr>
+                <a:srgbClr val="088192"/>
+              </a:buClr>
+              <a:buFont typeface="Arial"/>
+              <a:buChar char="•"/>
+            </a:pPr>
+            <a:r>
+              <a:rPr sz="2000" b="0" i="0">
+                <a:solidFill>
+                  <a:srgbClr val="051218"/>
+                </a:solidFill>
+                <a:latin typeface="Calibri"/>
+              </a:rPr>
+              <a:t>Labels come from politicians and media outlets, so an individual text may not match its label.</a:t>
+            </a:r>
+          </a:p>
+          <a:p>
+            <a:pPr algn="l" marL="274320" indent="-274320">
+              <a:lnSpc>
+                <a:spcPct val="105000"/>
+              </a:lnSpc>
+              <a:spcAft>
+                <a:spcPts val="2000"/>
+              </a:spcAft>
+              <a:buClr>
+                <a:srgbClr val="088192"/>
+              </a:buClr>
+              <a:buFont typeface="Arial"/>
+              <a:buChar char="•"/>
+            </a:pPr>
+            <a:r>
+              <a:rPr sz="2000" b="0" i="0">
+                <a:solidFill>
+                  <a:srgbClr val="051218"/>
+                </a:solidFill>
+                <a:latin typeface="Calibri"/>
+              </a:rPr>
+              <a:t>Tweet-trained models do not transfer reliably to article language.</a:t>
+            </a:r>
+          </a:p>
+          <a:p>
+            <a:pPr algn="l" marL="274320" indent="-274320">
+              <a:lnSpc>
+                <a:spcPct val="105000"/>
+              </a:lnSpc>
+              <a:spcAft>
+                <a:spcPts val="2000"/>
+              </a:spcAft>
+              <a:buClr>
+                <a:srgbClr val="088192"/>
+              </a:buClr>
+              <a:buFont typeface="Arial"/>
+              <a:buChar char="•"/>
+            </a:pPr>
+            <a:r>
+              <a:rPr sz="2000" b="0" i="0">
+                <a:solidFill>
+                  <a:srgbClr val="051218"/>
+                </a:solidFill>
+                <a:latin typeface="Calibri"/>
+              </a:rPr>
+              <a:t>The three-class article task peaks at 53.7% accuracy.</a:t>
+            </a:r>
+          </a:p>
+          <a:p>
+            <a:pPr algn="l" marL="274320" indent="-274320">
+              <a:lnSpc>
+                <a:spcPct val="105000"/>
+              </a:lnSpc>
+              <a:spcAft>
+                <a:spcPts val="2000"/>
+              </a:spcAft>
+              <a:buClr>
+                <a:srgbClr val="088192"/>
+              </a:buClr>
+              <a:buFont typeface="Arial"/>
+              <a:buChar char="•"/>
+            </a:pPr>
+            <a:r>
+              <a:rPr sz="2000" b="0" i="0">
+                <a:solidFill>
+                  <a:srgbClr val="051218"/>
+                </a:solidFill>
+                <a:latin typeface="Calibri"/>
+              </a:rPr>
+              <a:t>Next: collect article-level labels and test on later time periods and new outlets.</a:t>
+            </a:r>
+          </a:p>
+        </p:txBody>
+      </p:sp>
+      <p:sp>
+        <p:nvSpPr>
+          <p:cNvPr id="4" name="Footer band"/>
+          <p:cNvSpPr/>
+          <p:nvPr/>
+        </p:nvSpPr>
+        <p:spPr>
+          <a:xfrm>
+            <a:off x="0" y="6355080"/>
+            <a:ext cx="12191695" cy="502920"/>
+          </a:xfrm>
+          <a:prstGeom prst="rect">
+            <a:avLst/>
+          </a:prstGeom>
+          <a:solidFill>
+            <a:srgbClr val="053944"/>
+          </a:solidFill>
+          <a:ln>
+            <a:noFill/>
+          </a:ln>
+          <a:effectLst/>
+        </p:spPr>
+        <p:style>
+          <a:lnRef idx="1">
+            <a:schemeClr val="accent1"/>
+          </a:lnRef>
+          <a:fillRef idx="3">
+            <a:schemeClr val="accent1"/>
+          </a:fillRef>
+          <a:effectRef idx="2">
+            <a:schemeClr val="accent1"/>
+          </a:effectRef>
+          <a:fontRef idx="minor">
+            <a:schemeClr val="lt1"/>
+          </a:fontRef>
+        </p:style>
+        <p:txBody>
+          <a:bodyPr rtlCol="0" anchor="ctr"/>
+          <a:lstStyle/>
+          <a:p>
+            <a:pPr algn="ctr"/>
+          </a:p>
+        </p:txBody>
+      </p:sp>
+      <p:sp>
+        <p:nvSpPr>
+          <p:cNvPr id="5" name="Footer section"/>
+          <p:cNvSpPr txBox="1"/>
+          <p:nvPr/>
+        </p:nvSpPr>
+        <p:spPr>
+          <a:xfrm>
+            <a:off x="548640" y="6355080"/>
+            <a:ext cx="7315200" cy="502920"/>
+          </a:xfrm>
+          <a:prstGeom prst="rect">
+            <a:avLst/>
+          </a:prstGeom>
+          <a:noFill/>
+        </p:spPr>
+        <p:txBody>
+          <a:bodyPr wrap="square" lIns="0" rIns="0" tIns="0" bIns="0" anchor="ctr">
+            <a:spAutoFit/>
+          </a:bodyPr>
+          <a:lstStyle/>
+          <a:p>
+            <a:pPr algn="l">
+              <a:spcAft>
+                <a:spcPts val="0"/>
+              </a:spcAft>
+            </a:pPr>
+            <a:r>
+              <a:rPr sz="1100" b="0" i="0" spc="200">
+                <a:solidFill>
+                  <a:srgbClr val="F2EFE6"/>
+                </a:solidFill>
+                <a:latin typeface="Calibri"/>
+              </a:rPr>
+              <a:t>CONCLUSIONS</a:t>
+            </a:r>
+          </a:p>
+        </p:txBody>
+      </p:sp>
+      <p:sp>
+        <p:nvSpPr>
+          <p:cNvPr id="6" name="Slide number"/>
+          <p:cNvSpPr txBox="1"/>
+          <p:nvPr/>
+        </p:nvSpPr>
+        <p:spPr>
+          <a:xfrm>
+            <a:off x="9814255" y="6355080"/>
+            <a:ext cx="1828800" cy="502920"/>
+          </a:xfrm>
+          <a:prstGeom prst="rect">
+            <a:avLst/>
+          </a:prstGeom>
+          <a:noFill/>
+        </p:spPr>
+        <p:txBody>
+          <a:bodyPr wrap="square" lIns="0" rIns="0" tIns="0" bIns="0" anchor="ctr">
+            <a:spAutoFit/>
+          </a:bodyPr>
+          <a:lstStyle/>
+          <a:p>
+            <a:pPr algn="r">
+              <a:spcAft>
+                <a:spcPts val="0"/>
+              </a:spcAft>
+            </a:pPr>
+            <a:r>
+              <a:rPr sz="1100" b="1" i="0" spc="200">
+                <a:solidFill>
+                  <a:srgbClr val="BCAC79"/>
+                </a:solidFill>
+                <a:latin typeface="Calibri"/>
+              </a:rPr>
+              <a:t>16</a:t>
+            </a:r>
+          </a:p>
+        </p:txBody>
+      </p:sp>
+    </p:spTree>
+  </p:cSld>
+  <p:clrMapOvr>
+    <a:masterClrMapping/>
+  </p:clrMapOvr>
+</p:sld>
+</file>
+
+<file path=ppt/slides/slide17.xml><?xml version="1.0" encoding="utf-8"?>
+<p:sld xmlns:a="http://schemas.openxmlformats.org/drawingml/2006/main" xmlns:p="http://schemas.openxmlformats.org/presentationml/2006/main" xmlns:r="http://schemas.openxmlformats.org/officeDocument/2006/relationships">
+  <p:cSld>
+    <p:bg>
+      <p:bgPr>
+        <a:solidFill>
+          <a:srgbClr val="F2EFE6"/>
+        </a:solidFill>
+        <a:effectLst/>
+      </p:bgPr>
+    </p:bg>
+    <p:spTree>
+      <p:nvGrpSpPr>
+        <p:cNvPr id="1" name=""/>
+        <p:cNvGrpSpPr/>
+        <p:nvPr/>
+      </p:nvGrpSpPr>
+      <p:grpSpPr/>
+      <p:sp>
+        <p:nvSpPr>
+          <p:cNvPr id="2" name="Thank you panel"/>
+          <p:cNvSpPr/>
+          <p:nvPr/>
+        </p:nvSpPr>
+        <p:spPr>
+          <a:xfrm>
+            <a:off x="0" y="0"/>
+            <a:ext cx="8961120" cy="6858000"/>
+          </a:xfrm>
+          <a:prstGeom prst="rect">
+            <a:avLst/>
+          </a:prstGeom>
+          <a:solidFill>
+            <a:srgbClr val="051218"/>
+          </a:solidFill>
+          <a:ln>
+            <a:noFill/>
+          </a:ln>
+          <a:effectLst/>
+        </p:spPr>
+        <p:style>
+          <a:lnRef idx="1">
+            <a:schemeClr val="accent1"/>
+          </a:lnRef>
+          <a:fillRef idx="3">
+            <a:schemeClr val="accent1"/>
+          </a:fillRef>
+          <a:effectRef idx="2">
+            <a:schemeClr val="accent1"/>
+          </a:effectRef>
+          <a:fontRef idx="minor">
+            <a:schemeClr val="lt1"/>
+          </a:fontRef>
+        </p:style>
+        <p:txBody>
+          <a:bodyPr rtlCol="0" anchor="ctr"/>
+          <a:lstStyle/>
+          <a:p>
+            <a:pPr algn="ctr"/>
+          </a:p>
+        </p:txBody>
+      </p:sp>
+      <p:sp>
+        <p:nvSpPr>
+          <p:cNvPr id="3" name="Thank you text"/>
+          <p:cNvSpPr txBox="1"/>
+          <p:nvPr/>
+        </p:nvSpPr>
+        <p:spPr>
+          <a:xfrm>
+            <a:off x="914400" y="2011680"/>
+            <a:ext cx="7132320" cy="2743200"/>
+          </a:xfrm>
+          <a:prstGeom prst="rect">
+            <a:avLst/>
+          </a:prstGeom>
+          <a:noFill/>
+        </p:spPr>
+        <p:txBody>
+          <a:bodyPr wrap="square" lIns="0" rIns="0" tIns="0" bIns="0" anchor="ctr">
+            <a:spAutoFit/>
+          </a:bodyPr>
+          <a:lstStyle/>
+          <a:p>
+            <a:pPr algn="ctr">
+              <a:spcAft>
+                <a:spcPts val="1800"/>
+              </a:spcAft>
+            </a:pPr>
+            <a:r>
+              <a:rPr sz="4400" b="1" i="0" spc="600">
+                <a:solidFill>
+                  <a:srgbClr val="F2EFE6"/>
+                </a:solidFill>
+                <a:latin typeface="Georgia"/>
+              </a:rPr>
+              <a:t>THANK YOU</a:t>
+            </a:r>
+          </a:p>
+          <a:p>
+            <a:pPr algn="ctr">
+              <a:spcAft>
+                <a:spcPts val="0"/>
+              </a:spcAft>
+            </a:pPr>
+            <a:r>
+              <a:rPr sz="1800" b="0" i="0">
+                <a:solidFill>
+                  <a:srgbClr val="BCAC79"/>
+                </a:solidFill>
+                <a:latin typeface="Calibri"/>
+              </a:rPr>
+              <a:t>Political bias classification from tweets and news articles</a:t>
             </a:r>
           </a:p>
         </p:txBody>

</xml_diff>

<commit_message>
Add the random-split finding to the Results at a glance slide
</commit_message>
<xml_diff>
--- a/docs/slides/deck.pptx
+++ b/docs/slides/deck.pptx
@@ -7473,6 +7473,30 @@
             <a:spAutoFit/>
           </a:bodyPr>
           <a:lstStyle/>
+          <a:p>
+            <a:pPr algn="l" marL="274320" indent="-274320">
+              <a:lnSpc>
+                <a:spcPct val="105000"/>
+              </a:lnSpc>
+              <a:spcAft>
+                <a:spcPts val="1400"/>
+              </a:spcAft>
+              <a:buClr>
+                <a:srgbClr val="088192"/>
+              </a:buClr>
+              <a:buFont typeface="Arial"/>
+              <a:buChar char="•"/>
+            </a:pPr>
+            <a:r>
+              <a:rPr sz="1800" b="0" i="0">
+                <a:solidFill>
+                  <a:srgbClr val="051218"/>
+                </a:solidFill>
+                <a:latin typeface="Calibri"/>
+              </a:rPr>
+              <a:t>The paper's random split inflated tweet accuracy by 5.0 points; holding out whole politicians gives the honest number.</a:t>
+            </a:r>
+          </a:p>
           <a:p>
             <a:pPr algn="l" marL="274320" indent="-274320">
               <a:lnSpc>

</xml_diff>